<commit_message>
chore: update OTT platform presentation slides
</commit_message>
<xml_diff>
--- a/OTT_Platform_Presentation_v2.pptx
+++ b/OTT_Platform_Presentation_v2.pptx
@@ -1,26 +1,26 @@
 
 <file path=ppt/presentation.xml><?xml version="1.0" encoding="utf-8"?>
-<p:presentation xmlns:a="http://schemas.openxmlformats.org/drawingml/2006/main" xmlns:r="http://schemas.openxmlformats.org/officeDocument/2006/relationships" xmlns:p="http://schemas.openxmlformats.org/presentationml/2006/main" saveSubsetFonts="1" autoCompressPictures="0">
+<p:presentation xmlns:a="http://schemas.openxmlformats.org/drawingml/2006/main" xmlns:r="http://schemas.openxmlformats.org/officeDocument/2006/relationships" xmlns:p="http://schemas.openxmlformats.org/presentationml/2006/main" autoCompressPictures="0">
   <p:sldMasterIdLst>
     <p:sldMasterId id="2147483648" r:id="rId1"/>
   </p:sldMasterIdLst>
   <p:sldIdLst>
-    <p:sldId id="256" r:id="rId7"/>
-    <p:sldId id="257" r:id="rId8"/>
-    <p:sldId id="258" r:id="rId9"/>
-    <p:sldId id="259" r:id="rId10"/>
-    <p:sldId id="260" r:id="rId11"/>
-    <p:sldId id="261" r:id="rId12"/>
-    <p:sldId id="262" r:id="rId13"/>
-    <p:sldId id="263" r:id="rId14"/>
-    <p:sldId id="264" r:id="rId15"/>
-    <p:sldId id="265" r:id="rId16"/>
-    <p:sldId id="266" r:id="rId17"/>
-    <p:sldId id="267" r:id="rId18"/>
-    <p:sldId id="268" r:id="rId19"/>
-    <p:sldId id="269" r:id="rId20"/>
+    <p:sldId id="256" r:id="rId3"/>
+    <p:sldId id="257" r:id="rId4"/>
+    <p:sldId id="258" r:id="rId5"/>
+    <p:sldId id="259" r:id="rId6"/>
+    <p:sldId id="260" r:id="rId7"/>
+    <p:sldId id="261" r:id="rId8"/>
+    <p:sldId id="262" r:id="rId9"/>
+    <p:sldId id="263" r:id="rId10"/>
+    <p:sldId id="264" r:id="rId11"/>
+    <p:sldId id="265" r:id="rId12"/>
+    <p:sldId id="266" r:id="rId13"/>
+    <p:sldId id="267" r:id="rId14"/>
+    <p:sldId id="268" r:id="rId15"/>
+    <p:sldId id="269" r:id="rId16"/>
   </p:sldIdLst>
-  <p:sldSz cx="12191695" cy="6858000" type="screen4x3"/>
+  <p:sldSz cx="12191365" cy="6858000" type="screen4x3"/>
   <p:notesSz cx="6858000" cy="9144000"/>
   <p:defaultTextStyle>
     <a:defPPr>
@@ -117,6 +117,22 @@
       </a:defRPr>
     </a:lvl9pPr>
   </p:defaultTextStyle>
+  <p:extLst>
+    <p:ext uri="{EFAFB233-063F-42B5-8137-9DF3F51BA10A}">
+      <p15:sldGuideLst xmlns:p15="http://schemas.microsoft.com/office/powerpoint/2012/main">
+        <p15:guide id="1" orient="horz" pos="2160" userDrawn="1">
+          <p15:clr>
+            <a:srgbClr val="A4A3A4"/>
+          </p15:clr>
+        </p15:guide>
+        <p15:guide id="2" pos="2880" userDrawn="1">
+          <p15:clr>
+            <a:srgbClr val="A4A3A4"/>
+          </p15:clr>
+        </p15:guide>
+      </p15:sldGuideLst>
+    </p:ext>
+  </p:extLst>
 </p:presentation>
 </file>
 
@@ -301,7 +317,6 @@
           <a:p>
             <a:fld id="{5BCAD085-E8A6-8845-BD4E-CB4CCA059FC4}" type="datetimeFigureOut">
               <a:rPr lang="en-US" smtClean="0"/>
-              <a:t>1/27/13</a:t>
             </a:fld>
             <a:endParaRPr lang="en-US"/>
           </a:p>
@@ -343,18 +358,12 @@
           <a:p>
             <a:fld id="{C1FF6DA9-008F-8B48-92A6-B652298478BF}" type="slidenum">
               <a:rPr lang="en-US" smtClean="0"/>
-              <a:t>‹#›</a:t>
             </a:fld>
             <a:endParaRPr lang="en-US"/>
           </a:p>
         </p:txBody>
       </p:sp>
     </p:spTree>
-    <p:extLst>
-      <p:ext uri="{BB962C8B-B14F-4D97-AF65-F5344CB8AC3E}">
-        <p14:creationId xmlns:p14="http://schemas.microsoft.com/office/powerpoint/2010/main" val="3168075583"/>
-      </p:ext>
-    </p:extLst>
   </p:cSld>
   <p:clrMapOvr>
     <a:masterClrMapping/>
@@ -422,6 +431,7 @@
               <a:rPr lang="en-US" smtClean="0"/>
               <a:t>Click to edit Master text styles</a:t>
             </a:r>
+            <a:endParaRPr lang="en-US" smtClean="0"/>
           </a:p>
           <a:p>
             <a:pPr lvl="1"/>
@@ -429,6 +439,7 @@
               <a:rPr lang="en-US" smtClean="0"/>
               <a:t>Second level</a:t>
             </a:r>
+            <a:endParaRPr lang="en-US" smtClean="0"/>
           </a:p>
           <a:p>
             <a:pPr lvl="2"/>
@@ -436,6 +447,7 @@
               <a:rPr lang="en-US" smtClean="0"/>
               <a:t>Third level</a:t>
             </a:r>
+            <a:endParaRPr lang="en-US" smtClean="0"/>
           </a:p>
           <a:p>
             <a:pPr lvl="3"/>
@@ -443,6 +455,7 @@
               <a:rPr lang="en-US" smtClean="0"/>
               <a:t>Fourth level</a:t>
             </a:r>
+            <a:endParaRPr lang="en-US" smtClean="0"/>
           </a:p>
           <a:p>
             <a:pPr lvl="4"/>
@@ -471,7 +484,6 @@
           <a:p>
             <a:fld id="{5BCAD085-E8A6-8845-BD4E-CB4CCA059FC4}" type="datetimeFigureOut">
               <a:rPr lang="en-US" smtClean="0"/>
-              <a:t>1/27/13</a:t>
             </a:fld>
             <a:endParaRPr lang="en-US"/>
           </a:p>
@@ -513,18 +525,12 @@
           <a:p>
             <a:fld id="{C1FF6DA9-008F-8B48-92A6-B652298478BF}" type="slidenum">
               <a:rPr lang="en-US" smtClean="0"/>
-              <a:t>‹#›</a:t>
             </a:fld>
             <a:endParaRPr lang="en-US"/>
           </a:p>
         </p:txBody>
       </p:sp>
     </p:spTree>
-    <p:extLst>
-      <p:ext uri="{BB962C8B-B14F-4D97-AF65-F5344CB8AC3E}">
-        <p14:creationId xmlns:p14="http://schemas.microsoft.com/office/powerpoint/2010/main" val="2910927964"/>
-      </p:ext>
-    </p:extLst>
   </p:cSld>
   <p:clrMapOvr>
     <a:masterClrMapping/>
@@ -602,6 +608,7 @@
               <a:rPr lang="en-US" smtClean="0"/>
               <a:t>Click to edit Master text styles</a:t>
             </a:r>
+            <a:endParaRPr lang="en-US" smtClean="0"/>
           </a:p>
           <a:p>
             <a:pPr lvl="1"/>
@@ -609,6 +616,7 @@
               <a:rPr lang="en-US" smtClean="0"/>
               <a:t>Second level</a:t>
             </a:r>
+            <a:endParaRPr lang="en-US" smtClean="0"/>
           </a:p>
           <a:p>
             <a:pPr lvl="2"/>
@@ -616,6 +624,7 @@
               <a:rPr lang="en-US" smtClean="0"/>
               <a:t>Third level</a:t>
             </a:r>
+            <a:endParaRPr lang="en-US" smtClean="0"/>
           </a:p>
           <a:p>
             <a:pPr lvl="3"/>
@@ -623,6 +632,7 @@
               <a:rPr lang="en-US" smtClean="0"/>
               <a:t>Fourth level</a:t>
             </a:r>
+            <a:endParaRPr lang="en-US" smtClean="0"/>
           </a:p>
           <a:p>
             <a:pPr lvl="4"/>
@@ -651,7 +661,6 @@
           <a:p>
             <a:fld id="{5BCAD085-E8A6-8845-BD4E-CB4CCA059FC4}" type="datetimeFigureOut">
               <a:rPr lang="en-US" smtClean="0"/>
-              <a:t>1/27/13</a:t>
             </a:fld>
             <a:endParaRPr lang="en-US"/>
           </a:p>
@@ -693,18 +702,12 @@
           <a:p>
             <a:fld id="{C1FF6DA9-008F-8B48-92A6-B652298478BF}" type="slidenum">
               <a:rPr lang="en-US" smtClean="0"/>
-              <a:t>‹#›</a:t>
             </a:fld>
             <a:endParaRPr lang="en-US"/>
           </a:p>
         </p:txBody>
       </p:sp>
     </p:spTree>
-    <p:extLst>
-      <p:ext uri="{BB962C8B-B14F-4D97-AF65-F5344CB8AC3E}">
-        <p14:creationId xmlns:p14="http://schemas.microsoft.com/office/powerpoint/2010/main" val="3612223792"/>
-      </p:ext>
-    </p:extLst>
   </p:cSld>
   <p:clrMapOvr>
     <a:masterClrMapping/>
@@ -772,6 +775,7 @@
               <a:rPr lang="en-US" smtClean="0"/>
               <a:t>Click to edit Master text styles</a:t>
             </a:r>
+            <a:endParaRPr lang="en-US" smtClean="0"/>
           </a:p>
           <a:p>
             <a:pPr lvl="1"/>
@@ -779,6 +783,7 @@
               <a:rPr lang="en-US" smtClean="0"/>
               <a:t>Second level</a:t>
             </a:r>
+            <a:endParaRPr lang="en-US" smtClean="0"/>
           </a:p>
           <a:p>
             <a:pPr lvl="2"/>
@@ -786,6 +791,7 @@
               <a:rPr lang="en-US" smtClean="0"/>
               <a:t>Third level</a:t>
             </a:r>
+            <a:endParaRPr lang="en-US" smtClean="0"/>
           </a:p>
           <a:p>
             <a:pPr lvl="3"/>
@@ -793,6 +799,7 @@
               <a:rPr lang="en-US" smtClean="0"/>
               <a:t>Fourth level</a:t>
             </a:r>
+            <a:endParaRPr lang="en-US" smtClean="0"/>
           </a:p>
           <a:p>
             <a:pPr lvl="4"/>
@@ -821,7 +828,6 @@
           <a:p>
             <a:fld id="{5BCAD085-E8A6-8845-BD4E-CB4CCA059FC4}" type="datetimeFigureOut">
               <a:rPr lang="en-US" smtClean="0"/>
-              <a:t>1/27/13</a:t>
             </a:fld>
             <a:endParaRPr lang="en-US"/>
           </a:p>
@@ -863,18 +869,12 @@
           <a:p>
             <a:fld id="{C1FF6DA9-008F-8B48-92A6-B652298478BF}" type="slidenum">
               <a:rPr lang="en-US" smtClean="0"/>
-              <a:t>‹#›</a:t>
             </a:fld>
             <a:endParaRPr lang="en-US"/>
           </a:p>
         </p:txBody>
       </p:sp>
     </p:spTree>
-    <p:extLst>
-      <p:ext uri="{BB962C8B-B14F-4D97-AF65-F5344CB8AC3E}">
-        <p14:creationId xmlns:p14="http://schemas.microsoft.com/office/powerpoint/2010/main" val="2614314258"/>
-      </p:ext>
-    </p:extLst>
   </p:cSld>
   <p:clrMapOvr>
     <a:masterClrMapping/>
@@ -1047,6 +1047,7 @@
               <a:rPr lang="en-US" smtClean="0"/>
               <a:t>Click to edit Master text styles</a:t>
             </a:r>
+            <a:endParaRPr lang="en-US" smtClean="0"/>
           </a:p>
         </p:txBody>
       </p:sp>
@@ -1067,7 +1068,6 @@
           <a:p>
             <a:fld id="{5BCAD085-E8A6-8845-BD4E-CB4CCA059FC4}" type="datetimeFigureOut">
               <a:rPr lang="en-US" smtClean="0"/>
-              <a:t>1/27/13</a:t>
             </a:fld>
             <a:endParaRPr lang="en-US"/>
           </a:p>
@@ -1109,18 +1109,12 @@
           <a:p>
             <a:fld id="{C1FF6DA9-008F-8B48-92A6-B652298478BF}" type="slidenum">
               <a:rPr lang="en-US" smtClean="0"/>
-              <a:t>‹#›</a:t>
             </a:fld>
             <a:endParaRPr lang="en-US"/>
           </a:p>
         </p:txBody>
       </p:sp>
     </p:spTree>
-    <p:extLst>
-      <p:ext uri="{BB962C8B-B14F-4D97-AF65-F5344CB8AC3E}">
-        <p14:creationId xmlns:p14="http://schemas.microsoft.com/office/powerpoint/2010/main" val="960648375"/>
-      </p:ext>
-    </p:extLst>
   </p:cSld>
   <p:clrMapOvr>
     <a:masterClrMapping/>
@@ -1221,6 +1215,7 @@
               <a:rPr lang="en-US" smtClean="0"/>
               <a:t>Click to edit Master text styles</a:t>
             </a:r>
+            <a:endParaRPr lang="en-US" smtClean="0"/>
           </a:p>
           <a:p>
             <a:pPr lvl="1"/>
@@ -1228,6 +1223,7 @@
               <a:rPr lang="en-US" smtClean="0"/>
               <a:t>Second level</a:t>
             </a:r>
+            <a:endParaRPr lang="en-US" smtClean="0"/>
           </a:p>
           <a:p>
             <a:pPr lvl="2"/>
@@ -1235,6 +1231,7 @@
               <a:rPr lang="en-US" smtClean="0"/>
               <a:t>Third level</a:t>
             </a:r>
+            <a:endParaRPr lang="en-US" smtClean="0"/>
           </a:p>
           <a:p>
             <a:pPr lvl="3"/>
@@ -1242,6 +1239,7 @@
               <a:rPr lang="en-US" smtClean="0"/>
               <a:t>Fourth level</a:t>
             </a:r>
+            <a:endParaRPr lang="en-US" smtClean="0"/>
           </a:p>
           <a:p>
             <a:pPr lvl="4"/>
@@ -1306,6 +1304,7 @@
               <a:rPr lang="en-US" smtClean="0"/>
               <a:t>Click to edit Master text styles</a:t>
             </a:r>
+            <a:endParaRPr lang="en-US" smtClean="0"/>
           </a:p>
           <a:p>
             <a:pPr lvl="1"/>
@@ -1313,6 +1312,7 @@
               <a:rPr lang="en-US" smtClean="0"/>
               <a:t>Second level</a:t>
             </a:r>
+            <a:endParaRPr lang="en-US" smtClean="0"/>
           </a:p>
           <a:p>
             <a:pPr lvl="2"/>
@@ -1320,6 +1320,7 @@
               <a:rPr lang="en-US" smtClean="0"/>
               <a:t>Third level</a:t>
             </a:r>
+            <a:endParaRPr lang="en-US" smtClean="0"/>
           </a:p>
           <a:p>
             <a:pPr lvl="3"/>
@@ -1327,6 +1328,7 @@
               <a:rPr lang="en-US" smtClean="0"/>
               <a:t>Fourth level</a:t>
             </a:r>
+            <a:endParaRPr lang="en-US" smtClean="0"/>
           </a:p>
           <a:p>
             <a:pPr lvl="4"/>
@@ -1355,7 +1357,6 @@
           <a:p>
             <a:fld id="{5BCAD085-E8A6-8845-BD4E-CB4CCA059FC4}" type="datetimeFigureOut">
               <a:rPr lang="en-US" smtClean="0"/>
-              <a:t>1/27/13</a:t>
             </a:fld>
             <a:endParaRPr lang="en-US"/>
           </a:p>
@@ -1397,18 +1398,12 @@
           <a:p>
             <a:fld id="{C1FF6DA9-008F-8B48-92A6-B652298478BF}" type="slidenum">
               <a:rPr lang="en-US" smtClean="0"/>
-              <a:t>‹#›</a:t>
             </a:fld>
             <a:endParaRPr lang="en-US"/>
           </a:p>
         </p:txBody>
       </p:sp>
     </p:spTree>
-    <p:extLst>
-      <p:ext uri="{BB962C8B-B14F-4D97-AF65-F5344CB8AC3E}">
-        <p14:creationId xmlns:p14="http://schemas.microsoft.com/office/powerpoint/2010/main" val="2782244947"/>
-      </p:ext>
-    </p:extLst>
   </p:cSld>
   <p:clrMapOvr>
     <a:masterClrMapping/>
@@ -1522,6 +1517,7 @@
               <a:rPr lang="en-US" smtClean="0"/>
               <a:t>Click to edit Master text styles</a:t>
             </a:r>
+            <a:endParaRPr lang="en-US" smtClean="0"/>
           </a:p>
         </p:txBody>
       </p:sp>
@@ -1578,6 +1574,7 @@
               <a:rPr lang="en-US" smtClean="0"/>
               <a:t>Click to edit Master text styles</a:t>
             </a:r>
+            <a:endParaRPr lang="en-US" smtClean="0"/>
           </a:p>
           <a:p>
             <a:pPr lvl="1"/>
@@ -1585,6 +1582,7 @@
               <a:rPr lang="en-US" smtClean="0"/>
               <a:t>Second level</a:t>
             </a:r>
+            <a:endParaRPr lang="en-US" smtClean="0"/>
           </a:p>
           <a:p>
             <a:pPr lvl="2"/>
@@ -1592,6 +1590,7 @@
               <a:rPr lang="en-US" smtClean="0"/>
               <a:t>Third level</a:t>
             </a:r>
+            <a:endParaRPr lang="en-US" smtClean="0"/>
           </a:p>
           <a:p>
             <a:pPr lvl="3"/>
@@ -1599,6 +1598,7 @@
               <a:rPr lang="en-US" smtClean="0"/>
               <a:t>Fourth level</a:t>
             </a:r>
+            <a:endParaRPr lang="en-US" smtClean="0"/>
           </a:p>
           <a:p>
             <a:pPr lvl="4"/>
@@ -1672,6 +1672,7 @@
               <a:rPr lang="en-US" smtClean="0"/>
               <a:t>Click to edit Master text styles</a:t>
             </a:r>
+            <a:endParaRPr lang="en-US" smtClean="0"/>
           </a:p>
         </p:txBody>
       </p:sp>
@@ -1728,6 +1729,7 @@
               <a:rPr lang="en-US" smtClean="0"/>
               <a:t>Click to edit Master text styles</a:t>
             </a:r>
+            <a:endParaRPr lang="en-US" smtClean="0"/>
           </a:p>
           <a:p>
             <a:pPr lvl="1"/>
@@ -1735,6 +1737,7 @@
               <a:rPr lang="en-US" smtClean="0"/>
               <a:t>Second level</a:t>
             </a:r>
+            <a:endParaRPr lang="en-US" smtClean="0"/>
           </a:p>
           <a:p>
             <a:pPr lvl="2"/>
@@ -1742,6 +1745,7 @@
               <a:rPr lang="en-US" smtClean="0"/>
               <a:t>Third level</a:t>
             </a:r>
+            <a:endParaRPr lang="en-US" smtClean="0"/>
           </a:p>
           <a:p>
             <a:pPr lvl="3"/>
@@ -1749,6 +1753,7 @@
               <a:rPr lang="en-US" smtClean="0"/>
               <a:t>Fourth level</a:t>
             </a:r>
+            <a:endParaRPr lang="en-US" smtClean="0"/>
           </a:p>
           <a:p>
             <a:pPr lvl="4"/>
@@ -1777,7 +1782,6 @@
           <a:p>
             <a:fld id="{5BCAD085-E8A6-8845-BD4E-CB4CCA059FC4}" type="datetimeFigureOut">
               <a:rPr lang="en-US" smtClean="0"/>
-              <a:t>1/27/13</a:t>
             </a:fld>
             <a:endParaRPr lang="en-US"/>
           </a:p>
@@ -1819,18 +1823,12 @@
           <a:p>
             <a:fld id="{C1FF6DA9-008F-8B48-92A6-B652298478BF}" type="slidenum">
               <a:rPr lang="en-US" smtClean="0"/>
-              <a:t>‹#›</a:t>
             </a:fld>
             <a:endParaRPr lang="en-US"/>
           </a:p>
         </p:txBody>
       </p:sp>
     </p:spTree>
-    <p:extLst>
-      <p:ext uri="{BB962C8B-B14F-4D97-AF65-F5344CB8AC3E}">
-        <p14:creationId xmlns:p14="http://schemas.microsoft.com/office/powerpoint/2010/main" val="990158736"/>
-      </p:ext>
-    </p:extLst>
   </p:cSld>
   <p:clrMapOvr>
     <a:masterClrMapping/>
@@ -1895,7 +1893,6 @@
           <a:p>
             <a:fld id="{5BCAD085-E8A6-8845-BD4E-CB4CCA059FC4}" type="datetimeFigureOut">
               <a:rPr lang="en-US" smtClean="0"/>
-              <a:t>1/27/13</a:t>
             </a:fld>
             <a:endParaRPr lang="en-US"/>
           </a:p>
@@ -1937,18 +1934,12 @@
           <a:p>
             <a:fld id="{C1FF6DA9-008F-8B48-92A6-B652298478BF}" type="slidenum">
               <a:rPr lang="en-US" smtClean="0"/>
-              <a:t>‹#›</a:t>
             </a:fld>
             <a:endParaRPr lang="en-US"/>
           </a:p>
         </p:txBody>
       </p:sp>
     </p:spTree>
-    <p:extLst>
-      <p:ext uri="{BB962C8B-B14F-4D97-AF65-F5344CB8AC3E}">
-        <p14:creationId xmlns:p14="http://schemas.microsoft.com/office/powerpoint/2010/main" val="727027711"/>
-      </p:ext>
-    </p:extLst>
   </p:cSld>
   <p:clrMapOvr>
     <a:masterClrMapping/>
@@ -1990,7 +1981,6 @@
           <a:p>
             <a:fld id="{5BCAD085-E8A6-8845-BD4E-CB4CCA059FC4}" type="datetimeFigureOut">
               <a:rPr lang="en-US" smtClean="0"/>
-              <a:t>1/27/13</a:t>
             </a:fld>
             <a:endParaRPr lang="en-US"/>
           </a:p>
@@ -2032,18 +2022,12 @@
           <a:p>
             <a:fld id="{C1FF6DA9-008F-8B48-92A6-B652298478BF}" type="slidenum">
               <a:rPr lang="en-US" smtClean="0"/>
-              <a:t>‹#›</a:t>
             </a:fld>
             <a:endParaRPr lang="en-US"/>
           </a:p>
         </p:txBody>
       </p:sp>
     </p:spTree>
-    <p:extLst>
-      <p:ext uri="{BB962C8B-B14F-4D97-AF65-F5344CB8AC3E}">
-        <p14:creationId xmlns:p14="http://schemas.microsoft.com/office/powerpoint/2010/main" val="1212999818"/>
-      </p:ext>
-    </p:extLst>
   </p:cSld>
   <p:clrMapOvr>
     <a:masterClrMapping/>
@@ -2153,6 +2137,7 @@
               <a:rPr lang="en-US" smtClean="0"/>
               <a:t>Click to edit Master text styles</a:t>
             </a:r>
+            <a:endParaRPr lang="en-US" smtClean="0"/>
           </a:p>
           <a:p>
             <a:pPr lvl="1"/>
@@ -2160,6 +2145,7 @@
               <a:rPr lang="en-US" smtClean="0"/>
               <a:t>Second level</a:t>
             </a:r>
+            <a:endParaRPr lang="en-US" smtClean="0"/>
           </a:p>
           <a:p>
             <a:pPr lvl="2"/>
@@ -2167,6 +2153,7 @@
               <a:rPr lang="en-US" smtClean="0"/>
               <a:t>Third level</a:t>
             </a:r>
+            <a:endParaRPr lang="en-US" smtClean="0"/>
           </a:p>
           <a:p>
             <a:pPr lvl="3"/>
@@ -2174,6 +2161,7 @@
               <a:rPr lang="en-US" smtClean="0"/>
               <a:t>Fourth level</a:t>
             </a:r>
+            <a:endParaRPr lang="en-US" smtClean="0"/>
           </a:p>
           <a:p>
             <a:pPr lvl="4"/>
@@ -2247,6 +2235,7 @@
               <a:rPr lang="en-US" smtClean="0"/>
               <a:t>Click to edit Master text styles</a:t>
             </a:r>
+            <a:endParaRPr lang="en-US" smtClean="0"/>
           </a:p>
         </p:txBody>
       </p:sp>
@@ -2267,7 +2256,6 @@
           <a:p>
             <a:fld id="{5BCAD085-E8A6-8845-BD4E-CB4CCA059FC4}" type="datetimeFigureOut">
               <a:rPr lang="en-US" smtClean="0"/>
-              <a:t>1/27/13</a:t>
             </a:fld>
             <a:endParaRPr lang="en-US"/>
           </a:p>
@@ -2309,18 +2297,12 @@
           <a:p>
             <a:fld id="{C1FF6DA9-008F-8B48-92A6-B652298478BF}" type="slidenum">
               <a:rPr lang="en-US" smtClean="0"/>
-              <a:t>‹#›</a:t>
             </a:fld>
             <a:endParaRPr lang="en-US"/>
           </a:p>
         </p:txBody>
       </p:sp>
     </p:spTree>
-    <p:extLst>
-      <p:ext uri="{BB962C8B-B14F-4D97-AF65-F5344CB8AC3E}">
-        <p14:creationId xmlns:p14="http://schemas.microsoft.com/office/powerpoint/2010/main" val="1840726560"/>
-      </p:ext>
-    </p:extLst>
   </p:cSld>
   <p:clrMapOvr>
     <a:masterClrMapping/>
@@ -2500,6 +2482,7 @@
               <a:rPr lang="en-US" smtClean="0"/>
               <a:t>Click to edit Master text styles</a:t>
             </a:r>
+            <a:endParaRPr lang="en-US" smtClean="0"/>
           </a:p>
         </p:txBody>
       </p:sp>
@@ -2520,7 +2503,6 @@
           <a:p>
             <a:fld id="{5BCAD085-E8A6-8845-BD4E-CB4CCA059FC4}" type="datetimeFigureOut">
               <a:rPr lang="en-US" smtClean="0"/>
-              <a:t>1/27/13</a:t>
             </a:fld>
             <a:endParaRPr lang="en-US"/>
           </a:p>
@@ -2562,18 +2544,12 @@
           <a:p>
             <a:fld id="{C1FF6DA9-008F-8B48-92A6-B652298478BF}" type="slidenum">
               <a:rPr lang="en-US" smtClean="0"/>
-              <a:t>‹#›</a:t>
             </a:fld>
             <a:endParaRPr lang="en-US"/>
           </a:p>
         </p:txBody>
       </p:sp>
     </p:spTree>
-    <p:extLst>
-      <p:ext uri="{BB962C8B-B14F-4D97-AF65-F5344CB8AC3E}">
-        <p14:creationId xmlns:p14="http://schemas.microsoft.com/office/powerpoint/2010/main" val="3889236939"/>
-      </p:ext>
-    </p:extLst>
   </p:cSld>
   <p:clrMapOvr>
     <a:masterClrMapping/>
@@ -2666,6 +2642,7 @@
               <a:rPr lang="en-US" smtClean="0"/>
               <a:t>Click to edit Master text styles</a:t>
             </a:r>
+            <a:endParaRPr lang="en-US" smtClean="0"/>
           </a:p>
           <a:p>
             <a:pPr lvl="1"/>
@@ -2673,6 +2650,7 @@
               <a:rPr lang="en-US" smtClean="0"/>
               <a:t>Second level</a:t>
             </a:r>
+            <a:endParaRPr lang="en-US" smtClean="0"/>
           </a:p>
           <a:p>
             <a:pPr lvl="2"/>
@@ -2680,6 +2658,7 @@
               <a:rPr lang="en-US" smtClean="0"/>
               <a:t>Third level</a:t>
             </a:r>
+            <a:endParaRPr lang="en-US" smtClean="0"/>
           </a:p>
           <a:p>
             <a:pPr lvl="3"/>
@@ -2687,6 +2666,7 @@
               <a:rPr lang="en-US" smtClean="0"/>
               <a:t>Fourth level</a:t>
             </a:r>
+            <a:endParaRPr lang="en-US" smtClean="0"/>
           </a:p>
           <a:p>
             <a:pPr lvl="4"/>
@@ -2733,7 +2713,6 @@
           <a:p>
             <a:fld id="{5BCAD085-E8A6-8845-BD4E-CB4CCA059FC4}" type="datetimeFigureOut">
               <a:rPr lang="en-US" smtClean="0"/>
-              <a:t>1/27/13</a:t>
             </a:fld>
             <a:endParaRPr lang="en-US"/>
           </a:p>
@@ -2811,18 +2790,12 @@
           <a:p>
             <a:fld id="{C1FF6DA9-008F-8B48-92A6-B652298478BF}" type="slidenum">
               <a:rPr lang="en-US" smtClean="0"/>
-              <a:t>‹#›</a:t>
             </a:fld>
             <a:endParaRPr lang="en-US"/>
           </a:p>
         </p:txBody>
       </p:sp>
     </p:spTree>
-    <p:extLst>
-      <p:ext uri="{BB962C8B-B14F-4D97-AF65-F5344CB8AC3E}">
-        <p14:creationId xmlns:p14="http://schemas.microsoft.com/office/powerpoint/2010/main" val="2209977519"/>
-      </p:ext>
-    </p:extLst>
   </p:cSld>
   <p:clrMap bg1="lt1" tx1="dk1" bg2="lt2" tx2="dk2" accent1="accent1" accent2="accent2" accent3="accent3" accent4="accent4" accent5="accent5" accent6="accent6" hlink="hlink" folHlink="folHlink"/>
   <p:sldLayoutIdLst>
@@ -2860,7 +2833,7 @@
         <a:spcBef>
           <a:spcPct val="20000"/>
         </a:spcBef>
-        <a:buFont typeface="Arial"/>
+        <a:buFont typeface="Arial" panose="020B0604020202020204"/>
         <a:buChar char="•"/>
         <a:defRPr sz="3200" kern="1200">
           <a:solidFill>
@@ -2875,7 +2848,7 @@
         <a:spcBef>
           <a:spcPct val="20000"/>
         </a:spcBef>
-        <a:buFont typeface="Arial"/>
+        <a:buFont typeface="Arial" panose="020B0604020202020204"/>
         <a:buChar char="–"/>
         <a:defRPr sz="2800" kern="1200">
           <a:solidFill>
@@ -2890,7 +2863,7 @@
         <a:spcBef>
           <a:spcPct val="20000"/>
         </a:spcBef>
-        <a:buFont typeface="Arial"/>
+        <a:buFont typeface="Arial" panose="020B0604020202020204"/>
         <a:buChar char="•"/>
         <a:defRPr sz="2400" kern="1200">
           <a:solidFill>
@@ -2905,7 +2878,7 @@
         <a:spcBef>
           <a:spcPct val="20000"/>
         </a:spcBef>
-        <a:buFont typeface="Arial"/>
+        <a:buFont typeface="Arial" panose="020B0604020202020204"/>
         <a:buChar char="–"/>
         <a:defRPr sz="2000" kern="1200">
           <a:solidFill>
@@ -2920,7 +2893,7 @@
         <a:spcBef>
           <a:spcPct val="20000"/>
         </a:spcBef>
-        <a:buFont typeface="Arial"/>
+        <a:buFont typeface="Arial" panose="020B0604020202020204"/>
         <a:buChar char="»"/>
         <a:defRPr sz="2000" kern="1200">
           <a:solidFill>
@@ -2935,7 +2908,7 @@
         <a:spcBef>
           <a:spcPct val="20000"/>
         </a:spcBef>
-        <a:buFont typeface="Arial"/>
+        <a:buFont typeface="Arial" panose="020B0604020202020204"/>
         <a:buChar char="•"/>
         <a:defRPr sz="2000" kern="1200">
           <a:solidFill>
@@ -2950,7 +2923,7 @@
         <a:spcBef>
           <a:spcPct val="20000"/>
         </a:spcBef>
-        <a:buFont typeface="Arial"/>
+        <a:buFont typeface="Arial" panose="020B0604020202020204"/>
         <a:buChar char="•"/>
         <a:defRPr sz="2000" kern="1200">
           <a:solidFill>
@@ -2965,7 +2938,7 @@
         <a:spcBef>
           <a:spcPct val="20000"/>
         </a:spcBef>
-        <a:buFont typeface="Arial"/>
+        <a:buFont typeface="Arial" panose="020B0604020202020204"/>
         <a:buChar char="•"/>
         <a:defRPr sz="2000" kern="1200">
           <a:solidFill>
@@ -2980,7 +2953,7 @@
         <a:spcBef>
           <a:spcPct val="20000"/>
         </a:spcBef>
-        <a:buFont typeface="Arial"/>
+        <a:buFont typeface="Arial" panose="020B0604020202020204"/>
         <a:buChar char="•"/>
         <a:defRPr sz="2000" kern="1200">
           <a:solidFill>
@@ -3092,7 +3065,7 @@
 </file>
 
 <file path=ppt/slides/slide1.xml><?xml version="1.0" encoding="utf-8"?>
-<p:sld xmlns:a="http://schemas.openxmlformats.org/drawingml/2006/main" xmlns:p="http://schemas.openxmlformats.org/presentationml/2006/main" xmlns:r="http://schemas.openxmlformats.org/officeDocument/2006/relationships">
+<p:sld xmlns:a="http://schemas.openxmlformats.org/drawingml/2006/main" xmlns:r="http://schemas.openxmlformats.org/officeDocument/2006/relationships" xmlns:p="http://schemas.openxmlformats.org/presentationml/2006/main">
   <p:cSld>
     <p:bg>
       <p:bgPr>
@@ -3179,7 +3152,7 @@
                 <a:solidFill>
                   <a:srgbClr val="FFFFFF"/>
                 </a:solidFill>
-                <a:latin typeface="Calibri"/>
+                <a:latin typeface="Calibri" panose="020F0502020204030204"/>
               </a:defRPr>
             </a:pPr>
             <a:r>
@@ -3215,7 +3188,7 @@
                 <a:solidFill>
                   <a:srgbClr val="6C5CE7"/>
                 </a:solidFill>
-                <a:latin typeface="Calibri"/>
+                <a:latin typeface="Calibri" panose="020F0502020204030204"/>
               </a:defRPr>
             </a:pPr>
             <a:r>
@@ -3294,7 +3267,7 @@
                 <a:solidFill>
                   <a:srgbClr val="B0B0C0"/>
                 </a:solidFill>
-                <a:latin typeface="Calibri"/>
+                <a:latin typeface="Calibri" panose="020F0502020204030204"/>
               </a:defRPr>
             </a:pPr>
             <a:r>
@@ -3379,7 +3352,7 @@
                 <a:solidFill>
                   <a:srgbClr val="00B4D8"/>
                 </a:solidFill>
-                <a:latin typeface="Calibri"/>
+                <a:latin typeface="Calibri" panose="020F0502020204030204"/>
               </a:defRPr>
             </a:pPr>
             <a:r>
@@ -3460,7 +3433,7 @@
                 <a:solidFill>
                   <a:srgbClr val="00B4D8"/>
                 </a:solidFill>
-                <a:latin typeface="Calibri"/>
+                <a:latin typeface="Calibri" panose="020F0502020204030204"/>
               </a:defRPr>
             </a:pPr>
             <a:r>
@@ -3541,7 +3514,7 @@
                 <a:solidFill>
                   <a:srgbClr val="00B894"/>
                 </a:solidFill>
-                <a:latin typeface="Calibri"/>
+                <a:latin typeface="Calibri" panose="020F0502020204030204"/>
               </a:defRPr>
             </a:pPr>
             <a:r>
@@ -3622,7 +3595,7 @@
                 <a:solidFill>
                   <a:srgbClr val="00B4D8"/>
                 </a:solidFill>
-                <a:latin typeface="Calibri"/>
+                <a:latin typeface="Calibri" panose="020F0502020204030204"/>
               </a:defRPr>
             </a:pPr>
             <a:r>
@@ -3703,7 +3676,7 @@
                 <a:solidFill>
                   <a:srgbClr val="FF6348"/>
                 </a:solidFill>
-                <a:latin typeface="Calibri"/>
+                <a:latin typeface="Calibri" panose="020F0502020204030204"/>
               </a:defRPr>
             </a:pPr>
             <a:r>
@@ -3721,7 +3694,7 @@
 </file>
 
 <file path=ppt/slides/slide10.xml><?xml version="1.0" encoding="utf-8"?>
-<p:sld xmlns:a="http://schemas.openxmlformats.org/drawingml/2006/main" xmlns:p="http://schemas.openxmlformats.org/presentationml/2006/main" xmlns:r="http://schemas.openxmlformats.org/officeDocument/2006/relationships">
+<p:sld xmlns:a="http://schemas.openxmlformats.org/drawingml/2006/main" xmlns:r="http://schemas.openxmlformats.org/officeDocument/2006/relationships" xmlns:p="http://schemas.openxmlformats.org/presentationml/2006/main">
   <p:cSld>
     <p:bg>
       <p:bgPr>
@@ -3808,7 +3781,7 @@
                 <a:solidFill>
                   <a:srgbClr val="FFD700"/>
                 </a:solidFill>
-                <a:latin typeface="Calibri"/>
+                <a:latin typeface="Calibri" panose="020F0502020204030204"/>
               </a:defRPr>
             </a:pPr>
             <a:r>
@@ -3844,7 +3817,7 @@
                 <a:solidFill>
                   <a:srgbClr val="B0B0C0"/>
                 </a:solidFill>
-                <a:latin typeface="Calibri"/>
+                <a:latin typeface="Calibri" panose="020F0502020204030204"/>
               </a:defRPr>
             </a:pPr>
             <a:r>
@@ -3923,7 +3896,7 @@
                 <a:solidFill>
                   <a:srgbClr val="0F0F1A"/>
                 </a:solidFill>
-                <a:latin typeface="Calibri"/>
+                <a:latin typeface="Calibri" panose="020F0502020204030204"/>
               </a:defRPr>
             </a:pPr>
             <a:r>
@@ -4002,7 +3975,7 @@
                 <a:solidFill>
                   <a:srgbClr val="0F0F1A"/>
                 </a:solidFill>
-                <a:latin typeface="Calibri"/>
+                <a:latin typeface="Calibri" panose="020F0502020204030204"/>
               </a:defRPr>
             </a:pPr>
             <a:r>
@@ -4081,7 +4054,7 @@
                 <a:solidFill>
                   <a:srgbClr val="0F0F1A"/>
                 </a:solidFill>
-                <a:latin typeface="Calibri"/>
+                <a:latin typeface="Calibri" panose="020F0502020204030204"/>
               </a:defRPr>
             </a:pPr>
             <a:r>
@@ -4160,7 +4133,7 @@
                 <a:solidFill>
                   <a:srgbClr val="0F0F1A"/>
                 </a:solidFill>
-                <a:latin typeface="Calibri"/>
+                <a:latin typeface="Calibri" panose="020F0502020204030204"/>
               </a:defRPr>
             </a:pPr>
             <a:r>
@@ -4239,7 +4212,7 @@
                 <a:solidFill>
                   <a:srgbClr val="0F0F1A"/>
                 </a:solidFill>
-                <a:latin typeface="Calibri"/>
+                <a:latin typeface="Calibri" panose="020F0502020204030204"/>
               </a:defRPr>
             </a:pPr>
             <a:r>
@@ -4318,7 +4291,7 @@
                 <a:solidFill>
                   <a:srgbClr val="0F0F1A"/>
                 </a:solidFill>
-                <a:latin typeface="Calibri"/>
+                <a:latin typeface="Calibri" panose="020F0502020204030204"/>
               </a:defRPr>
             </a:pPr>
             <a:r>
@@ -4397,7 +4370,7 @@
                 <a:solidFill>
                   <a:srgbClr val="FFFFFF"/>
                 </a:solidFill>
-                <a:latin typeface="Calibri"/>
+                <a:latin typeface="Calibri" panose="020F0502020204030204"/>
               </a:defRPr>
             </a:pPr>
             <a:r>
@@ -4476,7 +4449,7 @@
                 <a:solidFill>
                   <a:srgbClr val="FFFFFF"/>
                 </a:solidFill>
-                <a:latin typeface="Calibri"/>
+                <a:latin typeface="Calibri" panose="020F0502020204030204"/>
               </a:defRPr>
             </a:pPr>
             <a:r>
@@ -4555,7 +4528,7 @@
                 <a:solidFill>
                   <a:srgbClr val="FFFFFF"/>
                 </a:solidFill>
-                <a:latin typeface="Calibri"/>
+                <a:latin typeface="Calibri" panose="020F0502020204030204"/>
               </a:defRPr>
             </a:pPr>
             <a:r>
@@ -4634,7 +4607,7 @@
                 <a:solidFill>
                   <a:srgbClr val="FF6348"/>
                 </a:solidFill>
-                <a:latin typeface="Calibri"/>
+                <a:latin typeface="Calibri" panose="020F0502020204030204"/>
               </a:defRPr>
             </a:pPr>
             <a:r>
@@ -4713,7 +4686,7 @@
                 <a:solidFill>
                   <a:srgbClr val="00B894"/>
                 </a:solidFill>
-                <a:latin typeface="Calibri"/>
+                <a:latin typeface="Calibri" panose="020F0502020204030204"/>
               </a:defRPr>
             </a:pPr>
             <a:r>
@@ -4792,7 +4765,7 @@
                 <a:solidFill>
                   <a:srgbClr val="FFD700"/>
                 </a:solidFill>
-                <a:latin typeface="Calibri"/>
+                <a:latin typeface="Calibri" panose="020F0502020204030204"/>
               </a:defRPr>
             </a:pPr>
             <a:r>
@@ -4871,7 +4844,7 @@
                 <a:solidFill>
                   <a:srgbClr val="FFFFFF"/>
                 </a:solidFill>
-                <a:latin typeface="Calibri"/>
+                <a:latin typeface="Calibri" panose="020F0502020204030204"/>
               </a:defRPr>
             </a:pPr>
             <a:r>
@@ -4950,7 +4923,7 @@
                 <a:solidFill>
                   <a:srgbClr val="FFFFFF"/>
                 </a:solidFill>
-                <a:latin typeface="Calibri"/>
+                <a:latin typeface="Calibri" panose="020F0502020204030204"/>
               </a:defRPr>
             </a:pPr>
             <a:r>
@@ -5029,7 +5002,7 @@
                 <a:solidFill>
                   <a:srgbClr val="FFFFFF"/>
                 </a:solidFill>
-                <a:latin typeface="Calibri"/>
+                <a:latin typeface="Calibri" panose="020F0502020204030204"/>
               </a:defRPr>
             </a:pPr>
             <a:r>
@@ -5108,7 +5081,7 @@
                 <a:solidFill>
                   <a:srgbClr val="FF6348"/>
                 </a:solidFill>
-                <a:latin typeface="Calibri"/>
+                <a:latin typeface="Calibri" panose="020F0502020204030204"/>
               </a:defRPr>
             </a:pPr>
             <a:r>
@@ -5187,7 +5160,7 @@
                 <a:solidFill>
                   <a:srgbClr val="00B894"/>
                 </a:solidFill>
-                <a:latin typeface="Calibri"/>
+                <a:latin typeface="Calibri" panose="020F0502020204030204"/>
               </a:defRPr>
             </a:pPr>
             <a:r>
@@ -5266,7 +5239,7 @@
                 <a:solidFill>
                   <a:srgbClr val="FFD700"/>
                 </a:solidFill>
-                <a:latin typeface="Calibri"/>
+                <a:latin typeface="Calibri" panose="020F0502020204030204"/>
               </a:defRPr>
             </a:pPr>
             <a:r>
@@ -5345,7 +5318,7 @@
                 <a:solidFill>
                   <a:srgbClr val="FFFFFF"/>
                 </a:solidFill>
-                <a:latin typeface="Calibri"/>
+                <a:latin typeface="Calibri" panose="020F0502020204030204"/>
               </a:defRPr>
             </a:pPr>
             <a:r>
@@ -5424,7 +5397,7 @@
                 <a:solidFill>
                   <a:srgbClr val="FFFFFF"/>
                 </a:solidFill>
-                <a:latin typeface="Calibri"/>
+                <a:latin typeface="Calibri" panose="020F0502020204030204"/>
               </a:defRPr>
             </a:pPr>
             <a:r>
@@ -5503,7 +5476,7 @@
                 <a:solidFill>
                   <a:srgbClr val="FFFFFF"/>
                 </a:solidFill>
-                <a:latin typeface="Calibri"/>
+                <a:latin typeface="Calibri" panose="020F0502020204030204"/>
               </a:defRPr>
             </a:pPr>
             <a:r>
@@ -5582,7 +5555,7 @@
                 <a:solidFill>
                   <a:srgbClr val="FF6348"/>
                 </a:solidFill>
-                <a:latin typeface="Calibri"/>
+                <a:latin typeface="Calibri" panose="020F0502020204030204"/>
               </a:defRPr>
             </a:pPr>
             <a:r>
@@ -5661,7 +5634,7 @@
                 <a:solidFill>
                   <a:srgbClr val="00B894"/>
                 </a:solidFill>
-                <a:latin typeface="Calibri"/>
+                <a:latin typeface="Calibri" panose="020F0502020204030204"/>
               </a:defRPr>
             </a:pPr>
             <a:r>
@@ -5740,7 +5713,7 @@
                 <a:solidFill>
                   <a:srgbClr val="FFD700"/>
                 </a:solidFill>
-                <a:latin typeface="Calibri"/>
+                <a:latin typeface="Calibri" panose="020F0502020204030204"/>
               </a:defRPr>
             </a:pPr>
             <a:r>
@@ -5819,7 +5792,7 @@
                 <a:solidFill>
                   <a:srgbClr val="FFFFFF"/>
                 </a:solidFill>
-                <a:latin typeface="Calibri"/>
+                <a:latin typeface="Calibri" panose="020F0502020204030204"/>
               </a:defRPr>
             </a:pPr>
             <a:r>
@@ -5898,7 +5871,7 @@
                 <a:solidFill>
                   <a:srgbClr val="FFFFFF"/>
                 </a:solidFill>
-                <a:latin typeface="Calibri"/>
+                <a:latin typeface="Calibri" panose="020F0502020204030204"/>
               </a:defRPr>
             </a:pPr>
             <a:r>
@@ -5977,7 +5950,7 @@
                 <a:solidFill>
                   <a:srgbClr val="FFFFFF"/>
                 </a:solidFill>
-                <a:latin typeface="Calibri"/>
+                <a:latin typeface="Calibri" panose="020F0502020204030204"/>
               </a:defRPr>
             </a:pPr>
             <a:r>
@@ -6056,7 +6029,7 @@
                 <a:solidFill>
                   <a:srgbClr val="FF6348"/>
                 </a:solidFill>
-                <a:latin typeface="Calibri"/>
+                <a:latin typeface="Calibri" panose="020F0502020204030204"/>
               </a:defRPr>
             </a:pPr>
             <a:r>
@@ -6135,7 +6108,7 @@
                 <a:solidFill>
                   <a:srgbClr val="00B894"/>
                 </a:solidFill>
-                <a:latin typeface="Calibri"/>
+                <a:latin typeface="Calibri" panose="020F0502020204030204"/>
               </a:defRPr>
             </a:pPr>
             <a:r>
@@ -6214,7 +6187,7 @@
                 <a:solidFill>
                   <a:srgbClr val="FFD700"/>
                 </a:solidFill>
-                <a:latin typeface="Calibri"/>
+                <a:latin typeface="Calibri" panose="020F0502020204030204"/>
               </a:defRPr>
             </a:pPr>
             <a:r>
@@ -6295,7 +6268,7 @@
                 <a:solidFill>
                   <a:srgbClr val="FFD700"/>
                 </a:solidFill>
-                <a:latin typeface="Calibri"/>
+                <a:latin typeface="Calibri" panose="020F0502020204030204"/>
               </a:defRPr>
             </a:pPr>
             <a:r>
@@ -6331,7 +6304,7 @@
                 <a:solidFill>
                   <a:srgbClr val="B0B0C0"/>
                 </a:solidFill>
-                <a:latin typeface="Calibri"/>
+                <a:latin typeface="Calibri" panose="020F0502020204030204"/>
               </a:defRPr>
             </a:pPr>
             <a:r>
@@ -6357,7 +6330,7 @@
 </file>
 
 <file path=ppt/slides/slide11.xml><?xml version="1.0" encoding="utf-8"?>
-<p:sld xmlns:a="http://schemas.openxmlformats.org/drawingml/2006/main" xmlns:p="http://schemas.openxmlformats.org/presentationml/2006/main" xmlns:r="http://schemas.openxmlformats.org/officeDocument/2006/relationships">
+<p:sld xmlns:a="http://schemas.openxmlformats.org/drawingml/2006/main" xmlns:r="http://schemas.openxmlformats.org/officeDocument/2006/relationships" xmlns:p="http://schemas.openxmlformats.org/presentationml/2006/main">
   <p:cSld>
     <p:bg>
       <p:bgPr>
@@ -6444,7 +6417,7 @@
                 <a:solidFill>
                   <a:srgbClr val="00B4D8"/>
                 </a:solidFill>
-                <a:latin typeface="Calibri"/>
+                <a:latin typeface="Calibri" panose="020F0502020204030204"/>
               </a:defRPr>
             </a:pPr>
             <a:r>
@@ -6568,7 +6541,7 @@
                 <a:solidFill>
                   <a:srgbClr val="0F0F1A"/>
                 </a:solidFill>
-                <a:latin typeface="Calibri"/>
+                <a:latin typeface="Calibri" panose="020F0502020204030204"/>
               </a:defRPr>
             </a:pPr>
             <a:r>
@@ -6604,7 +6577,7 @@
                 <a:solidFill>
                   <a:srgbClr val="FFFFFF"/>
                 </a:solidFill>
-                <a:latin typeface="Calibri"/>
+                <a:latin typeface="Calibri" panose="020F0502020204030204"/>
               </a:defRPr>
             </a:pPr>
             <a:r>
@@ -6640,7 +6613,7 @@
                 <a:solidFill>
                   <a:srgbClr val="B0B0C0"/>
                 </a:solidFill>
-                <a:latin typeface="Calibri"/>
+                <a:latin typeface="Calibri" panose="020F0502020204030204"/>
               </a:defRPr>
             </a:pPr>
             <a:r>
@@ -6776,7 +6749,7 @@
                 <a:solidFill>
                   <a:srgbClr val="0F0F1A"/>
                 </a:solidFill>
-                <a:latin typeface="Calibri"/>
+                <a:latin typeface="Calibri" panose="020F0502020204030204"/>
               </a:defRPr>
             </a:pPr>
             <a:r>
@@ -6812,7 +6785,7 @@
                 <a:solidFill>
                   <a:srgbClr val="FFFFFF"/>
                 </a:solidFill>
-                <a:latin typeface="Calibri"/>
+                <a:latin typeface="Calibri" panose="020F0502020204030204"/>
               </a:defRPr>
             </a:pPr>
             <a:r>
@@ -6848,7 +6821,7 @@
                 <a:solidFill>
                   <a:srgbClr val="B0B0C0"/>
                 </a:solidFill>
-                <a:latin typeface="Calibri"/>
+                <a:latin typeface="Calibri" panose="020F0502020204030204"/>
               </a:defRPr>
             </a:pPr>
             <a:r>
@@ -6984,7 +6957,7 @@
                 <a:solidFill>
                   <a:srgbClr val="0F0F1A"/>
                 </a:solidFill>
-                <a:latin typeface="Calibri"/>
+                <a:latin typeface="Calibri" panose="020F0502020204030204"/>
               </a:defRPr>
             </a:pPr>
             <a:r>
@@ -7020,7 +6993,7 @@
                 <a:solidFill>
                   <a:srgbClr val="FFFFFF"/>
                 </a:solidFill>
-                <a:latin typeface="Calibri"/>
+                <a:latin typeface="Calibri" panose="020F0502020204030204"/>
               </a:defRPr>
             </a:pPr>
             <a:r>
@@ -7056,7 +7029,7 @@
                 <a:solidFill>
                   <a:srgbClr val="B0B0C0"/>
                 </a:solidFill>
-                <a:latin typeface="Calibri"/>
+                <a:latin typeface="Calibri" panose="020F0502020204030204"/>
               </a:defRPr>
             </a:pPr>
             <a:r>
@@ -7192,7 +7165,7 @@
                 <a:solidFill>
                   <a:srgbClr val="0F0F1A"/>
                 </a:solidFill>
-                <a:latin typeface="Calibri"/>
+                <a:latin typeface="Calibri" panose="020F0502020204030204"/>
               </a:defRPr>
             </a:pPr>
             <a:r>
@@ -7228,7 +7201,7 @@
                 <a:solidFill>
                   <a:srgbClr val="FFFFFF"/>
                 </a:solidFill>
-                <a:latin typeface="Calibri"/>
+                <a:latin typeface="Calibri" panose="020F0502020204030204"/>
               </a:defRPr>
             </a:pPr>
             <a:r>
@@ -7264,7 +7237,7 @@
                 <a:solidFill>
                   <a:srgbClr val="B0B0C0"/>
                 </a:solidFill>
-                <a:latin typeface="Calibri"/>
+                <a:latin typeface="Calibri" panose="020F0502020204030204"/>
               </a:defRPr>
             </a:pPr>
             <a:r>
@@ -7400,7 +7373,7 @@
                 <a:solidFill>
                   <a:srgbClr val="0F0F1A"/>
                 </a:solidFill>
-                <a:latin typeface="Calibri"/>
+                <a:latin typeface="Calibri" panose="020F0502020204030204"/>
               </a:defRPr>
             </a:pPr>
             <a:r>
@@ -7436,7 +7409,7 @@
                 <a:solidFill>
                   <a:srgbClr val="FFFFFF"/>
                 </a:solidFill>
-                <a:latin typeface="Calibri"/>
+                <a:latin typeface="Calibri" panose="020F0502020204030204"/>
               </a:defRPr>
             </a:pPr>
             <a:r>
@@ -7472,7 +7445,7 @@
                 <a:solidFill>
                   <a:srgbClr val="B0B0C0"/>
                 </a:solidFill>
-                <a:latin typeface="Calibri"/>
+                <a:latin typeface="Calibri" panose="020F0502020204030204"/>
               </a:defRPr>
             </a:pPr>
             <a:r>
@@ -7608,7 +7581,7 @@
                 <a:solidFill>
                   <a:srgbClr val="0F0F1A"/>
                 </a:solidFill>
-                <a:latin typeface="Calibri"/>
+                <a:latin typeface="Calibri" panose="020F0502020204030204"/>
               </a:defRPr>
             </a:pPr>
             <a:r>
@@ -7644,7 +7617,7 @@
                 <a:solidFill>
                   <a:srgbClr val="FFFFFF"/>
                 </a:solidFill>
-                <a:latin typeface="Calibri"/>
+                <a:latin typeface="Calibri" panose="020F0502020204030204"/>
               </a:defRPr>
             </a:pPr>
             <a:r>
@@ -7680,7 +7653,7 @@
                 <a:solidFill>
                   <a:srgbClr val="B0B0C0"/>
                 </a:solidFill>
-                <a:latin typeface="Calibri"/>
+                <a:latin typeface="Calibri" panose="020F0502020204030204"/>
               </a:defRPr>
             </a:pPr>
             <a:r>
@@ -7710,7 +7683,7 @@
 </file>
 
 <file path=ppt/slides/slide12.xml><?xml version="1.0" encoding="utf-8"?>
-<p:sld xmlns:a="http://schemas.openxmlformats.org/drawingml/2006/main" xmlns:p="http://schemas.openxmlformats.org/presentationml/2006/main" xmlns:r="http://schemas.openxmlformats.org/officeDocument/2006/relationships">
+<p:sld xmlns:a="http://schemas.openxmlformats.org/drawingml/2006/main" xmlns:r="http://schemas.openxmlformats.org/officeDocument/2006/relationships" xmlns:p="http://schemas.openxmlformats.org/presentationml/2006/main">
   <p:cSld>
     <p:bg>
       <p:bgPr>
@@ -7797,7 +7770,7 @@
                 <a:solidFill>
                   <a:srgbClr val="FFA000"/>
                 </a:solidFill>
-                <a:latin typeface="Calibri"/>
+                <a:latin typeface="Calibri" panose="020F0502020204030204"/>
               </a:defRPr>
             </a:pPr>
             <a:r>
@@ -7878,7 +7851,7 @@
                 <a:solidFill>
                   <a:srgbClr val="FFA000"/>
                 </a:solidFill>
-                <a:latin typeface="Calibri"/>
+                <a:latin typeface="Calibri" panose="020F0502020204030204"/>
               </a:defRPr>
             </a:pPr>
             <a:r>
@@ -7914,7 +7887,7 @@
                 <a:solidFill>
                   <a:srgbClr val="B0B0C0"/>
                 </a:solidFill>
-                <a:latin typeface="Calibri"/>
+                <a:latin typeface="Calibri" panose="020F0502020204030204"/>
               </a:defRPr>
             </a:pPr>
             <a:r>
@@ -7950,7 +7923,7 @@
                 <a:solidFill>
                   <a:srgbClr val="B0B0C0"/>
                 </a:solidFill>
-                <a:latin typeface="Calibri"/>
+                <a:latin typeface="Calibri" panose="020F0502020204030204"/>
               </a:defRPr>
             </a:pPr>
             <a:r>
@@ -7986,7 +7959,7 @@
                 <a:solidFill>
                   <a:srgbClr val="B0B0C0"/>
                 </a:solidFill>
-                <a:latin typeface="Calibri"/>
+                <a:latin typeface="Calibri" panose="020F0502020204030204"/>
               </a:defRPr>
             </a:pPr>
             <a:r>
@@ -8022,7 +7995,7 @@
                 <a:solidFill>
                   <a:srgbClr val="B0B0C0"/>
                 </a:solidFill>
-                <a:latin typeface="Calibri"/>
+                <a:latin typeface="Calibri" panose="020F0502020204030204"/>
               </a:defRPr>
             </a:pPr>
             <a:r>
@@ -8058,7 +8031,7 @@
                 <a:solidFill>
                   <a:srgbClr val="B0B0C0"/>
                 </a:solidFill>
-                <a:latin typeface="Calibri"/>
+                <a:latin typeface="Calibri" panose="020F0502020204030204"/>
               </a:defRPr>
             </a:pPr>
             <a:r>
@@ -8139,7 +8112,7 @@
                 <a:solidFill>
                   <a:srgbClr val="00B894"/>
                 </a:solidFill>
-                <a:latin typeface="Calibri"/>
+                <a:latin typeface="Calibri" panose="020F0502020204030204"/>
               </a:defRPr>
             </a:pPr>
             <a:r>
@@ -8175,7 +8148,7 @@
                 <a:solidFill>
                   <a:srgbClr val="B0B0C0"/>
                 </a:solidFill>
-                <a:latin typeface="Calibri"/>
+                <a:latin typeface="Calibri" panose="020F0502020204030204"/>
               </a:defRPr>
             </a:pPr>
             <a:r>
@@ -8211,7 +8184,7 @@
                 <a:solidFill>
                   <a:srgbClr val="B0B0C0"/>
                 </a:solidFill>
-                <a:latin typeface="Calibri"/>
+                <a:latin typeface="Calibri" panose="020F0502020204030204"/>
               </a:defRPr>
             </a:pPr>
             <a:r>
@@ -8247,7 +8220,7 @@
                 <a:solidFill>
                   <a:srgbClr val="B0B0C0"/>
                 </a:solidFill>
-                <a:latin typeface="Calibri"/>
+                <a:latin typeface="Calibri" panose="020F0502020204030204"/>
               </a:defRPr>
             </a:pPr>
             <a:r>
@@ -8283,7 +8256,7 @@
                 <a:solidFill>
                   <a:srgbClr val="B0B0C0"/>
                 </a:solidFill>
-                <a:latin typeface="Calibri"/>
+                <a:latin typeface="Calibri" panose="020F0502020204030204"/>
               </a:defRPr>
             </a:pPr>
             <a:r>
@@ -8319,7 +8292,7 @@
                 <a:solidFill>
                   <a:srgbClr val="B0B0C0"/>
                 </a:solidFill>
-                <a:latin typeface="Calibri"/>
+                <a:latin typeface="Calibri" panose="020F0502020204030204"/>
               </a:defRPr>
             </a:pPr>
             <a:r>
@@ -8337,7 +8310,7 @@
 </file>
 
 <file path=ppt/slides/slide13.xml><?xml version="1.0" encoding="utf-8"?>
-<p:sld xmlns:a="http://schemas.openxmlformats.org/drawingml/2006/main" xmlns:p="http://schemas.openxmlformats.org/presentationml/2006/main" xmlns:r="http://schemas.openxmlformats.org/officeDocument/2006/relationships">
+<p:sld xmlns:a="http://schemas.openxmlformats.org/drawingml/2006/main" xmlns:r="http://schemas.openxmlformats.org/officeDocument/2006/relationships" xmlns:p="http://schemas.openxmlformats.org/presentationml/2006/main">
   <p:cSld>
     <p:bg>
       <p:bgPr>
@@ -8424,7 +8397,7 @@
                 <a:solidFill>
                   <a:srgbClr val="00B894"/>
                 </a:solidFill>
-                <a:latin typeface="Calibri"/>
+                <a:latin typeface="Calibri" panose="020F0502020204030204"/>
               </a:defRPr>
             </a:pPr>
             <a:r>
@@ -8505,7 +8478,7 @@
                 <a:solidFill>
                   <a:srgbClr val="00B894"/>
                 </a:solidFill>
-                <a:latin typeface="Calibri"/>
+                <a:latin typeface="Calibri" panose="020F0502020204030204"/>
               </a:defRPr>
             </a:pPr>
             <a:r>
@@ -8541,7 +8514,7 @@
                 <a:solidFill>
                   <a:srgbClr val="B0B0C0"/>
                 </a:solidFill>
-                <a:latin typeface="Calibri"/>
+                <a:latin typeface="Calibri" panose="020F0502020204030204"/>
               </a:defRPr>
             </a:pPr>
             <a:r>
@@ -8626,7 +8599,7 @@
                 <a:solidFill>
                   <a:srgbClr val="FFD700"/>
                 </a:solidFill>
-                <a:latin typeface="Calibri"/>
+                <a:latin typeface="Calibri" panose="020F0502020204030204"/>
               </a:defRPr>
             </a:pPr>
             <a:r>
@@ -8662,7 +8635,7 @@
                 <a:solidFill>
                   <a:srgbClr val="B0B0C0"/>
                 </a:solidFill>
-                <a:latin typeface="Calibri"/>
+                <a:latin typeface="Calibri" panose="020F0502020204030204"/>
               </a:defRPr>
             </a:pPr>
             <a:r>
@@ -8747,7 +8720,7 @@
                 <a:solidFill>
                   <a:srgbClr val="00B4D8"/>
                 </a:solidFill>
-                <a:latin typeface="Calibri"/>
+                <a:latin typeface="Calibri" panose="020F0502020204030204"/>
               </a:defRPr>
             </a:pPr>
             <a:r>
@@ -8783,7 +8756,7 @@
                 <a:solidFill>
                   <a:srgbClr val="B0B0C0"/>
                 </a:solidFill>
-                <a:latin typeface="Calibri"/>
+                <a:latin typeface="Calibri" panose="020F0502020204030204"/>
               </a:defRPr>
             </a:pPr>
             <a:r>
@@ -8868,7 +8841,7 @@
                 <a:solidFill>
                   <a:srgbClr val="6C5CE7"/>
                 </a:solidFill>
-                <a:latin typeface="Calibri"/>
+                <a:latin typeface="Calibri" panose="020F0502020204030204"/>
               </a:defRPr>
             </a:pPr>
             <a:r>
@@ -8904,7 +8877,7 @@
                 <a:solidFill>
                   <a:srgbClr val="B0B0C0"/>
                 </a:solidFill>
-                <a:latin typeface="Calibri"/>
+                <a:latin typeface="Calibri" panose="020F0502020204030204"/>
               </a:defRPr>
             </a:pPr>
             <a:r>
@@ -8989,7 +8962,7 @@
                 <a:solidFill>
                   <a:srgbClr val="00B894"/>
                 </a:solidFill>
-                <a:latin typeface="Calibri"/>
+                <a:latin typeface="Calibri" panose="020F0502020204030204"/>
               </a:defRPr>
             </a:pPr>
             <a:r>
@@ -9025,7 +8998,7 @@
                 <a:solidFill>
                   <a:srgbClr val="B0B0C0"/>
                 </a:solidFill>
-                <a:latin typeface="Calibri"/>
+                <a:latin typeface="Calibri" panose="020F0502020204030204"/>
               </a:defRPr>
             </a:pPr>
             <a:r>
@@ -9061,7 +9034,7 @@
                 <a:solidFill>
                   <a:srgbClr val="B0B0C0"/>
                 </a:solidFill>
-                <a:latin typeface="Calibri"/>
+                <a:latin typeface="Calibri" panose="020F0502020204030204"/>
               </a:defRPr>
             </a:pPr>
             <a:r>
@@ -9097,7 +9070,7 @@
                 <a:solidFill>
                   <a:srgbClr val="B0B0C0"/>
                 </a:solidFill>
-                <a:latin typeface="Calibri"/>
+                <a:latin typeface="Calibri" panose="020F0502020204030204"/>
               </a:defRPr>
             </a:pPr>
             <a:r>
@@ -9133,7 +9106,7 @@
                 <a:solidFill>
                   <a:srgbClr val="B0B0C0"/>
                 </a:solidFill>
-                <a:latin typeface="Calibri"/>
+                <a:latin typeface="Calibri" panose="020F0502020204030204"/>
               </a:defRPr>
             </a:pPr>
             <a:r>
@@ -9169,7 +9142,7 @@
                 <a:solidFill>
                   <a:srgbClr val="B0B0C0"/>
                 </a:solidFill>
-                <a:latin typeface="Calibri"/>
+                <a:latin typeface="Calibri" panose="020F0502020204030204"/>
               </a:defRPr>
             </a:pPr>
             <a:r>
@@ -9187,7 +9160,7 @@
 </file>
 
 <file path=ppt/slides/slide14.xml><?xml version="1.0" encoding="utf-8"?>
-<p:sld xmlns:a="http://schemas.openxmlformats.org/drawingml/2006/main" xmlns:p="http://schemas.openxmlformats.org/presentationml/2006/main" xmlns:r="http://schemas.openxmlformats.org/officeDocument/2006/relationships">
+<p:sld xmlns:a="http://schemas.openxmlformats.org/drawingml/2006/main" xmlns:r="http://schemas.openxmlformats.org/officeDocument/2006/relationships" xmlns:p="http://schemas.openxmlformats.org/presentationml/2006/main">
   <p:cSld>
     <p:bg>
       <p:bgPr>
@@ -9274,7 +9247,7 @@
                 <a:solidFill>
                   <a:srgbClr val="FFFFFF"/>
                 </a:solidFill>
-                <a:latin typeface="Calibri"/>
+                <a:latin typeface="Calibri" panose="020F0502020204030204"/>
               </a:defRPr>
             </a:pPr>
             <a:r>
@@ -9310,7 +9283,7 @@
                 <a:solidFill>
                   <a:srgbClr val="6C5CE7"/>
                 </a:solidFill>
-                <a:latin typeface="Calibri"/>
+                <a:latin typeface="Calibri" panose="020F0502020204030204"/>
               </a:defRPr>
             </a:pPr>
             <a:r>
@@ -9389,7 +9362,7 @@
                 <a:solidFill>
                   <a:srgbClr val="808090"/>
                 </a:solidFill>
-                <a:latin typeface="Calibri"/>
+                <a:latin typeface="Calibri" panose="020F0502020204030204"/>
               </a:defRPr>
             </a:pPr>
             <a:r>
@@ -9425,7 +9398,7 @@
                 <a:solidFill>
                   <a:srgbClr val="B0B0C0"/>
                 </a:solidFill>
-                <a:latin typeface="Calibri"/>
+                <a:latin typeface="Calibri" panose="020F0502020204030204"/>
               </a:defRPr>
             </a:pPr>
             <a:r>
@@ -9443,7 +9416,7 @@
 </file>
 
 <file path=ppt/slides/slide2.xml><?xml version="1.0" encoding="utf-8"?>
-<p:sld xmlns:a="http://schemas.openxmlformats.org/drawingml/2006/main" xmlns:p="http://schemas.openxmlformats.org/presentationml/2006/main" xmlns:r="http://schemas.openxmlformats.org/officeDocument/2006/relationships">
+<p:sld xmlns:a="http://schemas.openxmlformats.org/drawingml/2006/main" xmlns:r="http://schemas.openxmlformats.org/officeDocument/2006/relationships" xmlns:p="http://schemas.openxmlformats.org/presentationml/2006/main">
   <p:cSld>
     <p:bg>
       <p:bgPr>
@@ -9530,7 +9503,7 @@
                 <a:solidFill>
                   <a:srgbClr val="FF6348"/>
                 </a:solidFill>
-                <a:latin typeface="Calibri"/>
+                <a:latin typeface="Calibri" panose="020F0502020204030204"/>
               </a:defRPr>
             </a:pPr>
             <a:r>
@@ -9566,7 +9539,7 @@
                 <a:solidFill>
                   <a:srgbClr val="B0B0C0"/>
                 </a:solidFill>
-                <a:latin typeface="Calibri"/>
+                <a:latin typeface="Calibri" panose="020F0502020204030204"/>
               </a:defRPr>
             </a:pPr>
             <a:r>
@@ -9647,7 +9620,7 @@
                 <a:solidFill>
                   <a:srgbClr val="FFFFFF"/>
                 </a:solidFill>
-                <a:latin typeface="Calibri"/>
+                <a:latin typeface="Calibri" panose="020F0502020204030204"/>
               </a:defRPr>
             </a:pPr>
             <a:r>
@@ -9683,7 +9656,7 @@
                 <a:solidFill>
                   <a:srgbClr val="FF6348"/>
                 </a:solidFill>
-                <a:latin typeface="Calibri"/>
+                <a:latin typeface="Calibri" panose="020F0502020204030204"/>
               </a:defRPr>
             </a:pPr>
             <a:r>
@@ -9719,7 +9692,7 @@
                 <a:solidFill>
                   <a:srgbClr val="B0B0C0"/>
                 </a:solidFill>
-                <a:latin typeface="Calibri"/>
+                <a:latin typeface="Calibri" panose="020F0502020204030204"/>
               </a:defRPr>
             </a:pPr>
             <a:r>
@@ -9804,7 +9777,7 @@
                 <a:solidFill>
                   <a:srgbClr val="FFFFFF"/>
                 </a:solidFill>
-                <a:latin typeface="Calibri"/>
+                <a:latin typeface="Calibri" panose="020F0502020204030204"/>
               </a:defRPr>
             </a:pPr>
             <a:r>
@@ -9840,7 +9813,7 @@
                 <a:solidFill>
                   <a:srgbClr val="FF6348"/>
                 </a:solidFill>
-                <a:latin typeface="Calibri"/>
+                <a:latin typeface="Calibri" panose="020F0502020204030204"/>
               </a:defRPr>
             </a:pPr>
             <a:r>
@@ -9876,7 +9849,7 @@
                 <a:solidFill>
                   <a:srgbClr val="B0B0C0"/>
                 </a:solidFill>
-                <a:latin typeface="Calibri"/>
+                <a:latin typeface="Calibri" panose="020F0502020204030204"/>
               </a:defRPr>
             </a:pPr>
             <a:r>
@@ -9961,7 +9934,7 @@
                 <a:solidFill>
                   <a:srgbClr val="FFFFFF"/>
                 </a:solidFill>
-                <a:latin typeface="Calibri"/>
+                <a:latin typeface="Calibri" panose="020F0502020204030204"/>
               </a:defRPr>
             </a:pPr>
             <a:r>
@@ -9997,7 +9970,7 @@
                 <a:solidFill>
                   <a:srgbClr val="FF6348"/>
                 </a:solidFill>
-                <a:latin typeface="Calibri"/>
+                <a:latin typeface="Calibri" panose="020F0502020204030204"/>
               </a:defRPr>
             </a:pPr>
             <a:r>
@@ -10033,7 +10006,7 @@
                 <a:solidFill>
                   <a:srgbClr val="B0B0C0"/>
                 </a:solidFill>
-                <a:latin typeface="Calibri"/>
+                <a:latin typeface="Calibri" panose="020F0502020204030204"/>
               </a:defRPr>
             </a:pPr>
             <a:r>
@@ -10118,7 +10091,7 @@
                 <a:solidFill>
                   <a:srgbClr val="FFFFFF"/>
                 </a:solidFill>
-                <a:latin typeface="Calibri"/>
+                <a:latin typeface="Calibri" panose="020F0502020204030204"/>
               </a:defRPr>
             </a:pPr>
             <a:r>
@@ -10154,7 +10127,7 @@
                 <a:solidFill>
                   <a:srgbClr val="FF6348"/>
                 </a:solidFill>
-                <a:latin typeface="Calibri"/>
+                <a:latin typeface="Calibri" panose="020F0502020204030204"/>
               </a:defRPr>
             </a:pPr>
             <a:r>
@@ -10190,7 +10163,7 @@
                 <a:solidFill>
                   <a:srgbClr val="B0B0C0"/>
                 </a:solidFill>
-                <a:latin typeface="Calibri"/>
+                <a:latin typeface="Calibri" panose="020F0502020204030204"/>
               </a:defRPr>
             </a:pPr>
             <a:r>
@@ -10230,7 +10203,7 @@
                 <a:solidFill>
                   <a:srgbClr val="B0B0C0"/>
                 </a:solidFill>
-                <a:latin typeface="Calibri"/>
+                <a:latin typeface="Calibri" panose="020F0502020204030204"/>
               </a:defRPr>
             </a:pPr>
             <a:r>
@@ -10311,7 +10284,7 @@
                 <a:solidFill>
                   <a:srgbClr val="FF6348"/>
                 </a:solidFill>
-                <a:latin typeface="Calibri"/>
+                <a:latin typeface="Calibri" panose="020F0502020204030204"/>
               </a:defRPr>
             </a:pPr>
             <a:r>
@@ -10347,7 +10320,7 @@
                 <a:solidFill>
                   <a:srgbClr val="808090"/>
                 </a:solidFill>
-                <a:latin typeface="Calibri"/>
+                <a:latin typeface="Calibri" panose="020F0502020204030204"/>
               </a:defRPr>
             </a:pPr>
             <a:r>
@@ -10365,7 +10338,7 @@
 </file>
 
 <file path=ppt/slides/slide3.xml><?xml version="1.0" encoding="utf-8"?>
-<p:sld xmlns:a="http://schemas.openxmlformats.org/drawingml/2006/main" xmlns:p="http://schemas.openxmlformats.org/presentationml/2006/main" xmlns:r="http://schemas.openxmlformats.org/officeDocument/2006/relationships">
+<p:sld xmlns:a="http://schemas.openxmlformats.org/drawingml/2006/main" xmlns:r="http://schemas.openxmlformats.org/officeDocument/2006/relationships" xmlns:p="http://schemas.openxmlformats.org/presentationml/2006/main">
   <p:cSld>
     <p:bg>
       <p:bgPr>
@@ -10452,7 +10425,7 @@
                 <a:solidFill>
                   <a:srgbClr val="00B894"/>
                 </a:solidFill>
-                <a:latin typeface="Calibri"/>
+                <a:latin typeface="Calibri" panose="020F0502020204030204"/>
               </a:defRPr>
             </a:pPr>
             <a:r>
@@ -10488,7 +10461,7 @@
                 <a:solidFill>
                   <a:srgbClr val="B0B0C0"/>
                 </a:solidFill>
-                <a:latin typeface="Calibri"/>
+                <a:latin typeface="Calibri" panose="020F0502020204030204"/>
               </a:defRPr>
             </a:pPr>
             <a:r>
@@ -10612,7 +10585,7 @@
                 <a:solidFill>
                   <a:srgbClr val="0F0F1A"/>
                 </a:solidFill>
-                <a:latin typeface="Calibri"/>
+                <a:latin typeface="Calibri" panose="020F0502020204030204"/>
               </a:defRPr>
             </a:pPr>
             <a:r>
@@ -10648,7 +10621,7 @@
                 <a:solidFill>
                   <a:srgbClr val="FFFFFF"/>
                 </a:solidFill>
-                <a:latin typeface="Calibri"/>
+                <a:latin typeface="Calibri" panose="020F0502020204030204"/>
               </a:defRPr>
             </a:pPr>
             <a:r>
@@ -10684,7 +10657,7 @@
                 <a:solidFill>
                   <a:srgbClr val="B0B0C0"/>
                 </a:solidFill>
-                <a:latin typeface="Calibri"/>
+                <a:latin typeface="Calibri" panose="020F0502020204030204"/>
               </a:defRPr>
             </a:pPr>
             <a:r>
@@ -10820,7 +10793,7 @@
                 <a:solidFill>
                   <a:srgbClr val="0F0F1A"/>
                 </a:solidFill>
-                <a:latin typeface="Calibri"/>
+                <a:latin typeface="Calibri" panose="020F0502020204030204"/>
               </a:defRPr>
             </a:pPr>
             <a:r>
@@ -10856,7 +10829,7 @@
                 <a:solidFill>
                   <a:srgbClr val="FFFFFF"/>
                 </a:solidFill>
-                <a:latin typeface="Calibri"/>
+                <a:latin typeface="Calibri" panose="020F0502020204030204"/>
               </a:defRPr>
             </a:pPr>
             <a:r>
@@ -10892,7 +10865,7 @@
                 <a:solidFill>
                   <a:srgbClr val="B0B0C0"/>
                 </a:solidFill>
-                <a:latin typeface="Calibri"/>
+                <a:latin typeface="Calibri" panose="020F0502020204030204"/>
               </a:defRPr>
             </a:pPr>
             <a:r>
@@ -11028,7 +11001,7 @@
                 <a:solidFill>
                   <a:srgbClr val="0F0F1A"/>
                 </a:solidFill>
-                <a:latin typeface="Calibri"/>
+                <a:latin typeface="Calibri" panose="020F0502020204030204"/>
               </a:defRPr>
             </a:pPr>
             <a:r>
@@ -11064,7 +11037,7 @@
                 <a:solidFill>
                   <a:srgbClr val="FFFFFF"/>
                 </a:solidFill>
-                <a:latin typeface="Calibri"/>
+                <a:latin typeface="Calibri" panose="020F0502020204030204"/>
               </a:defRPr>
             </a:pPr>
             <a:r>
@@ -11100,7 +11073,7 @@
                 <a:solidFill>
                   <a:srgbClr val="B0B0C0"/>
                 </a:solidFill>
-                <a:latin typeface="Calibri"/>
+                <a:latin typeface="Calibri" panose="020F0502020204030204"/>
               </a:defRPr>
             </a:pPr>
             <a:r>
@@ -11236,7 +11209,7 @@
                 <a:solidFill>
                   <a:srgbClr val="0F0F1A"/>
                 </a:solidFill>
-                <a:latin typeface="Calibri"/>
+                <a:latin typeface="Calibri" panose="020F0502020204030204"/>
               </a:defRPr>
             </a:pPr>
             <a:r>
@@ -11272,7 +11245,7 @@
                 <a:solidFill>
                   <a:srgbClr val="FFFFFF"/>
                 </a:solidFill>
-                <a:latin typeface="Calibri"/>
+                <a:latin typeface="Calibri" panose="020F0502020204030204"/>
               </a:defRPr>
             </a:pPr>
             <a:r>
@@ -11308,7 +11281,7 @@
                 <a:solidFill>
                   <a:srgbClr val="B0B0C0"/>
                 </a:solidFill>
-                <a:latin typeface="Calibri"/>
+                <a:latin typeface="Calibri" panose="020F0502020204030204"/>
               </a:defRPr>
             </a:pPr>
             <a:r>
@@ -11401,7 +11374,7 @@
                 <a:solidFill>
                   <a:srgbClr val="00B894"/>
                 </a:solidFill>
-                <a:latin typeface="Calibri"/>
+                <a:latin typeface="Calibri" panose="020F0502020204030204"/>
               </a:defRPr>
             </a:pPr>
             <a:r>
@@ -11437,7 +11410,7 @@
                 <a:solidFill>
                   <a:srgbClr val="B0B0C0"/>
                 </a:solidFill>
-                <a:latin typeface="Calibri"/>
+                <a:latin typeface="Calibri" panose="020F0502020204030204"/>
               </a:defRPr>
             </a:pPr>
             <a:r>
@@ -11455,7 +11428,7 @@
 </file>
 
 <file path=ppt/slides/slide4.xml><?xml version="1.0" encoding="utf-8"?>
-<p:sld xmlns:a="http://schemas.openxmlformats.org/drawingml/2006/main" xmlns:p="http://schemas.openxmlformats.org/presentationml/2006/main" xmlns:r="http://schemas.openxmlformats.org/officeDocument/2006/relationships">
+<p:sld xmlns:a="http://schemas.openxmlformats.org/drawingml/2006/main" xmlns:r="http://schemas.openxmlformats.org/officeDocument/2006/relationships" xmlns:p="http://schemas.openxmlformats.org/presentationml/2006/main">
   <p:cSld>
     <p:bg>
       <p:bgPr>
@@ -11542,7 +11515,7 @@
                 <a:solidFill>
                   <a:srgbClr val="6C5CE7"/>
                 </a:solidFill>
-                <a:latin typeface="Calibri"/>
+                <a:latin typeface="Calibri" panose="020F0502020204030204"/>
               </a:defRPr>
             </a:pPr>
             <a:r>
@@ -11623,7 +11596,7 @@
                 <a:solidFill>
                   <a:srgbClr val="FFFFFF"/>
                 </a:solidFill>
-                <a:latin typeface="Calibri"/>
+                <a:latin typeface="Calibri" panose="020F0502020204030204"/>
               </a:defRPr>
             </a:pPr>
             <a:r>
@@ -11702,7 +11675,7 @@
                 <a:solidFill>
                   <a:srgbClr val="0F0F1A"/>
                 </a:solidFill>
-                <a:latin typeface="Calibri"/>
+                <a:latin typeface="Calibri" panose="020F0502020204030204"/>
               </a:defRPr>
             </a:pPr>
             <a:r>
@@ -11738,7 +11711,7 @@
                 <a:solidFill>
                   <a:srgbClr val="9090A0"/>
                 </a:solidFill>
-                <a:latin typeface="Calibri"/>
+                <a:latin typeface="Calibri" panose="020F0502020204030204"/>
               </a:defRPr>
             </a:pPr>
             <a:r>
@@ -11774,7 +11747,7 @@
                 <a:solidFill>
                   <a:srgbClr val="9090A0"/>
                 </a:solidFill>
-                <a:latin typeface="Calibri"/>
+                <a:latin typeface="Calibri" panose="020F0502020204030204"/>
               </a:defRPr>
             </a:pPr>
             <a:r>
@@ -11810,7 +11783,7 @@
                 <a:solidFill>
                   <a:srgbClr val="9090A0"/>
                 </a:solidFill>
-                <a:latin typeface="Calibri"/>
+                <a:latin typeface="Calibri" panose="020F0502020204030204"/>
               </a:defRPr>
             </a:pPr>
             <a:r>
@@ -11846,7 +11819,7 @@
                 <a:solidFill>
                   <a:srgbClr val="9090A0"/>
                 </a:solidFill>
-                <a:latin typeface="Calibri"/>
+                <a:latin typeface="Calibri" panose="020F0502020204030204"/>
               </a:defRPr>
             </a:pPr>
             <a:r>
@@ -11882,7 +11855,7 @@
                 <a:solidFill>
                   <a:srgbClr val="9090A0"/>
                 </a:solidFill>
-                <a:latin typeface="Calibri"/>
+                <a:latin typeface="Calibri" panose="020F0502020204030204"/>
               </a:defRPr>
             </a:pPr>
             <a:r>
@@ -11963,7 +11936,7 @@
                 <a:solidFill>
                   <a:srgbClr val="FFFFFF"/>
                 </a:solidFill>
-                <a:latin typeface="Calibri"/>
+                <a:latin typeface="Calibri" panose="020F0502020204030204"/>
               </a:defRPr>
             </a:pPr>
             <a:r>
@@ -12042,7 +12015,7 @@
                 <a:solidFill>
                   <a:srgbClr val="0F0F1A"/>
                 </a:solidFill>
-                <a:latin typeface="Calibri"/>
+                <a:latin typeface="Calibri" panose="020F0502020204030204"/>
               </a:defRPr>
             </a:pPr>
             <a:r>
@@ -12078,7 +12051,7 @@
                 <a:solidFill>
                   <a:srgbClr val="00B894"/>
                 </a:solidFill>
-                <a:latin typeface="Calibri"/>
+                <a:latin typeface="Calibri" panose="020F0502020204030204"/>
               </a:defRPr>
             </a:pPr>
             <a:r>
@@ -12114,7 +12087,7 @@
                 <a:solidFill>
                   <a:srgbClr val="00B894"/>
                 </a:solidFill>
-                <a:latin typeface="Calibri"/>
+                <a:latin typeface="Calibri" panose="020F0502020204030204"/>
               </a:defRPr>
             </a:pPr>
             <a:r>
@@ -12150,7 +12123,7 @@
                 <a:solidFill>
                   <a:srgbClr val="00B894"/>
                 </a:solidFill>
-                <a:latin typeface="Calibri"/>
+                <a:latin typeface="Calibri" panose="020F0502020204030204"/>
               </a:defRPr>
             </a:pPr>
             <a:r>
@@ -12186,7 +12159,7 @@
                 <a:solidFill>
                   <a:srgbClr val="00B894"/>
                 </a:solidFill>
-                <a:latin typeface="Calibri"/>
+                <a:latin typeface="Calibri" panose="020F0502020204030204"/>
               </a:defRPr>
             </a:pPr>
             <a:r>
@@ -12222,7 +12195,7 @@
                 <a:solidFill>
                   <a:srgbClr val="00B894"/>
                 </a:solidFill>
-                <a:latin typeface="Calibri"/>
+                <a:latin typeface="Calibri" panose="020F0502020204030204"/>
               </a:defRPr>
             </a:pPr>
             <a:r>
@@ -12303,7 +12276,7 @@
                 <a:solidFill>
                   <a:srgbClr val="FFFFFF"/>
                 </a:solidFill>
-                <a:latin typeface="Calibri"/>
+                <a:latin typeface="Calibri" panose="020F0502020204030204"/>
               </a:defRPr>
             </a:pPr>
             <a:r>
@@ -12382,7 +12355,7 @@
                 <a:solidFill>
                   <a:srgbClr val="0F0F1A"/>
                 </a:solidFill>
-                <a:latin typeface="Calibri"/>
+                <a:latin typeface="Calibri" panose="020F0502020204030204"/>
               </a:defRPr>
             </a:pPr>
             <a:r>
@@ -12418,7 +12391,7 @@
                 <a:solidFill>
                   <a:srgbClr val="9090A0"/>
                 </a:solidFill>
-                <a:latin typeface="Calibri"/>
+                <a:latin typeface="Calibri" panose="020F0502020204030204"/>
               </a:defRPr>
             </a:pPr>
             <a:r>
@@ -12454,7 +12427,7 @@
                 <a:solidFill>
                   <a:srgbClr val="9090A0"/>
                 </a:solidFill>
-                <a:latin typeface="Calibri"/>
+                <a:latin typeface="Calibri" panose="020F0502020204030204"/>
               </a:defRPr>
             </a:pPr>
             <a:r>
@@ -12490,7 +12463,7 @@
                 <a:solidFill>
                   <a:srgbClr val="9090A0"/>
                 </a:solidFill>
-                <a:latin typeface="Calibri"/>
+                <a:latin typeface="Calibri" panose="020F0502020204030204"/>
               </a:defRPr>
             </a:pPr>
             <a:r>
@@ -12526,7 +12499,7 @@
                 <a:solidFill>
                   <a:srgbClr val="9090A0"/>
                 </a:solidFill>
-                <a:latin typeface="Calibri"/>
+                <a:latin typeface="Calibri" panose="020F0502020204030204"/>
               </a:defRPr>
             </a:pPr>
             <a:r>
@@ -12562,7 +12535,7 @@
                 <a:solidFill>
                   <a:srgbClr val="9090A0"/>
                 </a:solidFill>
-                <a:latin typeface="Calibri"/>
+                <a:latin typeface="Calibri" panose="020F0502020204030204"/>
               </a:defRPr>
             </a:pPr>
             <a:r>
@@ -12580,7 +12553,7 @@
 </file>
 
 <file path=ppt/slides/slide5.xml><?xml version="1.0" encoding="utf-8"?>
-<p:sld xmlns:a="http://schemas.openxmlformats.org/drawingml/2006/main" xmlns:p="http://schemas.openxmlformats.org/presentationml/2006/main" xmlns:r="http://schemas.openxmlformats.org/officeDocument/2006/relationships">
+<p:sld xmlns:a="http://schemas.openxmlformats.org/drawingml/2006/main" xmlns:r="http://schemas.openxmlformats.org/officeDocument/2006/relationships" xmlns:p="http://schemas.openxmlformats.org/presentationml/2006/main">
   <p:cSld>
     <p:bg>
       <p:bgPr>
@@ -12667,7 +12640,7 @@
                 <a:solidFill>
                   <a:srgbClr val="00B4D8"/>
                 </a:solidFill>
-                <a:latin typeface="Calibri"/>
+                <a:latin typeface="Calibri" panose="020F0502020204030204"/>
               </a:defRPr>
             </a:pPr>
             <a:r>
@@ -12748,7 +12721,7 @@
                 <a:solidFill>
                   <a:srgbClr val="6C5CE7"/>
                 </a:solidFill>
-                <a:latin typeface="Calibri"/>
+                <a:latin typeface="Calibri" panose="020F0502020204030204"/>
               </a:defRPr>
             </a:pPr>
             <a:r>
@@ -12827,7 +12800,7 @@
                 <a:solidFill>
                   <a:srgbClr val="B0B0C0"/>
                 </a:solidFill>
-                <a:latin typeface="Calibri"/>
+                <a:latin typeface="Calibri" panose="020F0502020204030204"/>
               </a:defRPr>
             </a:pPr>
             <a:r>
@@ -12863,7 +12836,7 @@
                 <a:solidFill>
                   <a:srgbClr val="B0B0C0"/>
                 </a:solidFill>
-                <a:latin typeface="Calibri"/>
+                <a:latin typeface="Calibri" panose="020F0502020204030204"/>
               </a:defRPr>
             </a:pPr>
             <a:r>
@@ -12899,7 +12872,7 @@
                 <a:solidFill>
                   <a:srgbClr val="B0B0C0"/>
                 </a:solidFill>
-                <a:latin typeface="Calibri"/>
+                <a:latin typeface="Calibri" panose="020F0502020204030204"/>
               </a:defRPr>
             </a:pPr>
             <a:r>
@@ -12935,7 +12908,7 @@
                 <a:solidFill>
                   <a:srgbClr val="B0B0C0"/>
                 </a:solidFill>
-                <a:latin typeface="Calibri"/>
+                <a:latin typeface="Calibri" panose="020F0502020204030204"/>
               </a:defRPr>
             </a:pPr>
             <a:r>
@@ -12971,7 +12944,7 @@
                 <a:solidFill>
                   <a:srgbClr val="B0B0C0"/>
                 </a:solidFill>
-                <a:latin typeface="Calibri"/>
+                <a:latin typeface="Calibri" panose="020F0502020204030204"/>
               </a:defRPr>
             </a:pPr>
             <a:r>
@@ -13007,7 +12980,7 @@
                 <a:solidFill>
                   <a:srgbClr val="B0B0C0"/>
                 </a:solidFill>
-                <a:latin typeface="Calibri"/>
+                <a:latin typeface="Calibri" panose="020F0502020204030204"/>
               </a:defRPr>
             </a:pPr>
             <a:r>
@@ -13043,7 +13016,7 @@
                 <a:solidFill>
                   <a:srgbClr val="B0B0C0"/>
                 </a:solidFill>
-                <a:latin typeface="Calibri"/>
+                <a:latin typeface="Calibri" panose="020F0502020204030204"/>
               </a:defRPr>
             </a:pPr>
             <a:r>
@@ -13124,7 +13097,7 @@
                 <a:solidFill>
                   <a:srgbClr val="00B894"/>
                 </a:solidFill>
-                <a:latin typeface="Calibri"/>
+                <a:latin typeface="Calibri" panose="020F0502020204030204"/>
               </a:defRPr>
             </a:pPr>
             <a:r>
@@ -13203,7 +13176,7 @@
                 <a:solidFill>
                   <a:srgbClr val="B0B0C0"/>
                 </a:solidFill>
-                <a:latin typeface="Calibri"/>
+                <a:latin typeface="Calibri" panose="020F0502020204030204"/>
               </a:defRPr>
             </a:pPr>
             <a:r>
@@ -13239,7 +13212,7 @@
                 <a:solidFill>
                   <a:srgbClr val="B0B0C0"/>
                 </a:solidFill>
-                <a:latin typeface="Calibri"/>
+                <a:latin typeface="Calibri" panose="020F0502020204030204"/>
               </a:defRPr>
             </a:pPr>
             <a:r>
@@ -13275,7 +13248,7 @@
                 <a:solidFill>
                   <a:srgbClr val="B0B0C0"/>
                 </a:solidFill>
-                <a:latin typeface="Calibri"/>
+                <a:latin typeface="Calibri" panose="020F0502020204030204"/>
               </a:defRPr>
             </a:pPr>
             <a:r>
@@ -13311,7 +13284,7 @@
                 <a:solidFill>
                   <a:srgbClr val="B0B0C0"/>
                 </a:solidFill>
-                <a:latin typeface="Calibri"/>
+                <a:latin typeface="Calibri" panose="020F0502020204030204"/>
               </a:defRPr>
             </a:pPr>
             <a:r>
@@ -13347,7 +13320,7 @@
                 <a:solidFill>
                   <a:srgbClr val="B0B0C0"/>
                 </a:solidFill>
-                <a:latin typeface="Calibri"/>
+                <a:latin typeface="Calibri" panose="020F0502020204030204"/>
               </a:defRPr>
             </a:pPr>
             <a:r>
@@ -13383,7 +13356,7 @@
                 <a:solidFill>
                   <a:srgbClr val="B0B0C0"/>
                 </a:solidFill>
-                <a:latin typeface="Calibri"/>
+                <a:latin typeface="Calibri" panose="020F0502020204030204"/>
               </a:defRPr>
             </a:pPr>
             <a:r>
@@ -13419,7 +13392,7 @@
                 <a:solidFill>
                   <a:srgbClr val="B0B0C0"/>
                 </a:solidFill>
-                <a:latin typeface="Calibri"/>
+                <a:latin typeface="Calibri" panose="020F0502020204030204"/>
               </a:defRPr>
             </a:pPr>
             <a:r>
@@ -13500,7 +13473,7 @@
                 <a:solidFill>
                   <a:srgbClr val="FFA000"/>
                 </a:solidFill>
-                <a:latin typeface="Calibri"/>
+                <a:latin typeface="Calibri" panose="020F0502020204030204"/>
               </a:defRPr>
             </a:pPr>
             <a:r>
@@ -13579,7 +13552,7 @@
                 <a:solidFill>
                   <a:srgbClr val="B0B0C0"/>
                 </a:solidFill>
-                <a:latin typeface="Calibri"/>
+                <a:latin typeface="Calibri" panose="020F0502020204030204"/>
               </a:defRPr>
             </a:pPr>
             <a:r>
@@ -13615,7 +13588,7 @@
                 <a:solidFill>
                   <a:srgbClr val="B0B0C0"/>
                 </a:solidFill>
-                <a:latin typeface="Calibri"/>
+                <a:latin typeface="Calibri" panose="020F0502020204030204"/>
               </a:defRPr>
             </a:pPr>
             <a:r>
@@ -13651,7 +13624,7 @@
                 <a:solidFill>
                   <a:srgbClr val="B0B0C0"/>
                 </a:solidFill>
-                <a:latin typeface="Calibri"/>
+                <a:latin typeface="Calibri" panose="020F0502020204030204"/>
               </a:defRPr>
             </a:pPr>
             <a:r>
@@ -13687,7 +13660,7 @@
                 <a:solidFill>
                   <a:srgbClr val="B0B0C0"/>
                 </a:solidFill>
-                <a:latin typeface="Calibri"/>
+                <a:latin typeface="Calibri" panose="020F0502020204030204"/>
               </a:defRPr>
             </a:pPr>
             <a:r>
@@ -13723,7 +13696,7 @@
                 <a:solidFill>
                   <a:srgbClr val="B0B0C0"/>
                 </a:solidFill>
-                <a:latin typeface="Calibri"/>
+                <a:latin typeface="Calibri" panose="020F0502020204030204"/>
               </a:defRPr>
             </a:pPr>
             <a:r>
@@ -13759,7 +13732,7 @@
                 <a:solidFill>
                   <a:srgbClr val="B0B0C0"/>
                 </a:solidFill>
-                <a:latin typeface="Calibri"/>
+                <a:latin typeface="Calibri" panose="020F0502020204030204"/>
               </a:defRPr>
             </a:pPr>
             <a:r>
@@ -13840,7 +13813,7 @@
                 <a:solidFill>
                   <a:srgbClr val="FF6348"/>
                 </a:solidFill>
-                <a:latin typeface="Calibri"/>
+                <a:latin typeface="Calibri" panose="020F0502020204030204"/>
               </a:defRPr>
             </a:pPr>
             <a:r>
@@ -13919,7 +13892,7 @@
                 <a:solidFill>
                   <a:srgbClr val="B0B0C0"/>
                 </a:solidFill>
-                <a:latin typeface="Calibri"/>
+                <a:latin typeface="Calibri" panose="020F0502020204030204"/>
               </a:defRPr>
             </a:pPr>
             <a:r>
@@ -13955,7 +13928,7 @@
                 <a:solidFill>
                   <a:srgbClr val="B0B0C0"/>
                 </a:solidFill>
-                <a:latin typeface="Calibri"/>
+                <a:latin typeface="Calibri" panose="020F0502020204030204"/>
               </a:defRPr>
             </a:pPr>
             <a:r>
@@ -13991,7 +13964,7 @@
                 <a:solidFill>
                   <a:srgbClr val="B0B0C0"/>
                 </a:solidFill>
-                <a:latin typeface="Calibri"/>
+                <a:latin typeface="Calibri" panose="020F0502020204030204"/>
               </a:defRPr>
             </a:pPr>
             <a:r>
@@ -14027,7 +14000,7 @@
                 <a:solidFill>
                   <a:srgbClr val="B0B0C0"/>
                 </a:solidFill>
-                <a:latin typeface="Calibri"/>
+                <a:latin typeface="Calibri" panose="020F0502020204030204"/>
               </a:defRPr>
             </a:pPr>
             <a:r>
@@ -14063,7 +14036,7 @@
                 <a:solidFill>
                   <a:srgbClr val="B0B0C0"/>
                 </a:solidFill>
-                <a:latin typeface="Calibri"/>
+                <a:latin typeface="Calibri" panose="020F0502020204030204"/>
               </a:defRPr>
             </a:pPr>
             <a:r>
@@ -14273,7 +14246,7 @@
                 <a:solidFill>
                   <a:srgbClr val="00B4D8"/>
                 </a:solidFill>
-                <a:latin typeface="Calibri"/>
+                <a:latin typeface="Calibri" panose="020F0502020204030204"/>
               </a:defRPr>
             </a:pPr>
             <a:r>
@@ -14291,7 +14264,7 @@
 </file>
 
 <file path=ppt/slides/slide6.xml><?xml version="1.0" encoding="utf-8"?>
-<p:sld xmlns:a="http://schemas.openxmlformats.org/drawingml/2006/main" xmlns:p="http://schemas.openxmlformats.org/presentationml/2006/main" xmlns:r="http://schemas.openxmlformats.org/officeDocument/2006/relationships">
+<p:sld xmlns:a="http://schemas.openxmlformats.org/drawingml/2006/main" xmlns:r="http://schemas.openxmlformats.org/officeDocument/2006/relationships" xmlns:p="http://schemas.openxmlformats.org/presentationml/2006/main">
   <p:cSld>
     <p:bg>
       <p:bgPr>
@@ -14378,7 +14351,7 @@
                 <a:solidFill>
                   <a:srgbClr val="FFD700"/>
                 </a:solidFill>
-                <a:latin typeface="Calibri"/>
+                <a:latin typeface="Calibri" panose="020F0502020204030204"/>
               </a:defRPr>
             </a:pPr>
             <a:r>
@@ -14459,7 +14432,7 @@
                 <a:solidFill>
                   <a:srgbClr val="6C5CE7"/>
                 </a:solidFill>
-                <a:latin typeface="Calibri"/>
+                <a:latin typeface="Calibri" panose="020F0502020204030204"/>
               </a:defRPr>
             </a:pPr>
             <a:r>
@@ -14540,7 +14513,7 @@
                 <a:solidFill>
                   <a:srgbClr val="FF6348"/>
                 </a:solidFill>
-                <a:latin typeface="Calibri"/>
+                <a:latin typeface="Calibri" panose="020F0502020204030204"/>
               </a:defRPr>
             </a:pPr>
             <a:r>
@@ -14621,7 +14594,7 @@
                 <a:solidFill>
                   <a:srgbClr val="00B894"/>
                 </a:solidFill>
-                <a:latin typeface="Calibri"/>
+                <a:latin typeface="Calibri" panose="020F0502020204030204"/>
               </a:defRPr>
             </a:pPr>
             <a:r>
@@ -14700,7 +14673,7 @@
                 <a:solidFill>
                   <a:srgbClr val="FFFFFF"/>
                 </a:solidFill>
-                <a:latin typeface="Calibri"/>
+                <a:latin typeface="Calibri" panose="020F0502020204030204"/>
               </a:defRPr>
             </a:pPr>
             <a:r>
@@ -14779,7 +14752,7 @@
                 <a:solidFill>
                   <a:srgbClr val="FF6348"/>
                 </a:solidFill>
-                <a:latin typeface="Calibri"/>
+                <a:latin typeface="Calibri" panose="020F0502020204030204"/>
               </a:defRPr>
             </a:pPr>
             <a:r>
@@ -14858,7 +14831,7 @@
                 <a:solidFill>
                   <a:srgbClr val="00B894"/>
                 </a:solidFill>
-                <a:latin typeface="Calibri"/>
+                <a:latin typeface="Calibri" panose="020F0502020204030204"/>
               </a:defRPr>
             </a:pPr>
             <a:r>
@@ -14937,7 +14910,7 @@
                 <a:solidFill>
                   <a:srgbClr val="FFFFFF"/>
                 </a:solidFill>
-                <a:latin typeface="Calibri"/>
+                <a:latin typeface="Calibri" panose="020F0502020204030204"/>
               </a:defRPr>
             </a:pPr>
             <a:r>
@@ -15016,7 +14989,7 @@
                 <a:solidFill>
                   <a:srgbClr val="FF6348"/>
                 </a:solidFill>
-                <a:latin typeface="Calibri"/>
+                <a:latin typeface="Calibri" panose="020F0502020204030204"/>
               </a:defRPr>
             </a:pPr>
             <a:r>
@@ -15095,7 +15068,7 @@
                 <a:solidFill>
                   <a:srgbClr val="00B894"/>
                 </a:solidFill>
-                <a:latin typeface="Calibri"/>
+                <a:latin typeface="Calibri" panose="020F0502020204030204"/>
               </a:defRPr>
             </a:pPr>
             <a:r>
@@ -15174,7 +15147,7 @@
                 <a:solidFill>
                   <a:srgbClr val="FFFFFF"/>
                 </a:solidFill>
-                <a:latin typeface="Calibri"/>
+                <a:latin typeface="Calibri" panose="020F0502020204030204"/>
               </a:defRPr>
             </a:pPr>
             <a:r>
@@ -15253,7 +15226,7 @@
                 <a:solidFill>
                   <a:srgbClr val="FF6348"/>
                 </a:solidFill>
-                <a:latin typeface="Calibri"/>
+                <a:latin typeface="Calibri" panose="020F0502020204030204"/>
               </a:defRPr>
             </a:pPr>
             <a:r>
@@ -15332,7 +15305,7 @@
                 <a:solidFill>
                   <a:srgbClr val="00B894"/>
                 </a:solidFill>
-                <a:latin typeface="Calibri"/>
+                <a:latin typeface="Calibri" panose="020F0502020204030204"/>
               </a:defRPr>
             </a:pPr>
             <a:r>
@@ -15411,7 +15384,7 @@
                 <a:solidFill>
                   <a:srgbClr val="FFFFFF"/>
                 </a:solidFill>
-                <a:latin typeface="Calibri"/>
+                <a:latin typeface="Calibri" panose="020F0502020204030204"/>
               </a:defRPr>
             </a:pPr>
             <a:r>
@@ -15490,7 +15463,7 @@
                 <a:solidFill>
                   <a:srgbClr val="FF6348"/>
                 </a:solidFill>
-                <a:latin typeface="Calibri"/>
+                <a:latin typeface="Calibri" panose="020F0502020204030204"/>
               </a:defRPr>
             </a:pPr>
             <a:r>
@@ -15569,7 +15542,7 @@
                 <a:solidFill>
                   <a:srgbClr val="00B894"/>
                 </a:solidFill>
-                <a:latin typeface="Calibri"/>
+                <a:latin typeface="Calibri" panose="020F0502020204030204"/>
               </a:defRPr>
             </a:pPr>
             <a:r>
@@ -15648,7 +15621,7 @@
                 <a:solidFill>
                   <a:srgbClr val="FFFFFF"/>
                 </a:solidFill>
-                <a:latin typeface="Calibri"/>
+                <a:latin typeface="Calibri" panose="020F0502020204030204"/>
               </a:defRPr>
             </a:pPr>
             <a:r>
@@ -15727,7 +15700,7 @@
                 <a:solidFill>
                   <a:srgbClr val="FF6348"/>
                 </a:solidFill>
-                <a:latin typeface="Calibri"/>
+                <a:latin typeface="Calibri" panose="020F0502020204030204"/>
               </a:defRPr>
             </a:pPr>
             <a:r>
@@ -15806,7 +15779,7 @@
                 <a:solidFill>
                   <a:srgbClr val="00B894"/>
                 </a:solidFill>
-                <a:latin typeface="Calibri"/>
+                <a:latin typeface="Calibri" panose="020F0502020204030204"/>
               </a:defRPr>
             </a:pPr>
             <a:r>
@@ -15885,7 +15858,7 @@
                 <a:solidFill>
                   <a:srgbClr val="FFFFFF"/>
                 </a:solidFill>
-                <a:latin typeface="Calibri"/>
+                <a:latin typeface="Calibri" panose="020F0502020204030204"/>
               </a:defRPr>
             </a:pPr>
             <a:r>
@@ -15964,7 +15937,7 @@
                 <a:solidFill>
                   <a:srgbClr val="FF6348"/>
                 </a:solidFill>
-                <a:latin typeface="Calibri"/>
+                <a:latin typeface="Calibri" panose="020F0502020204030204"/>
               </a:defRPr>
             </a:pPr>
             <a:r>
@@ -16043,7 +16016,7 @@
                 <a:solidFill>
                   <a:srgbClr val="00B894"/>
                 </a:solidFill>
-                <a:latin typeface="Calibri"/>
+                <a:latin typeface="Calibri" panose="020F0502020204030204"/>
               </a:defRPr>
             </a:pPr>
             <a:r>
@@ -16122,7 +16095,7 @@
                 <a:solidFill>
                   <a:srgbClr val="FFFFFF"/>
                 </a:solidFill>
-                <a:latin typeface="Calibri"/>
+                <a:latin typeface="Calibri" panose="020F0502020204030204"/>
               </a:defRPr>
             </a:pPr>
             <a:r>
@@ -16201,7 +16174,7 @@
                 <a:solidFill>
                   <a:srgbClr val="FF6348"/>
                 </a:solidFill>
-                <a:latin typeface="Calibri"/>
+                <a:latin typeface="Calibri" panose="020F0502020204030204"/>
               </a:defRPr>
             </a:pPr>
             <a:r>
@@ -16280,7 +16253,7 @@
                 <a:solidFill>
                   <a:srgbClr val="00B894"/>
                 </a:solidFill>
-                <a:latin typeface="Calibri"/>
+                <a:latin typeface="Calibri" panose="020F0502020204030204"/>
               </a:defRPr>
             </a:pPr>
             <a:r>
@@ -16361,7 +16334,7 @@
                 <a:solidFill>
                   <a:srgbClr val="FFFFFF"/>
                 </a:solidFill>
-                <a:latin typeface="Calibri"/>
+                <a:latin typeface="Calibri" panose="020F0502020204030204"/>
               </a:defRPr>
             </a:pPr>
             <a:r>
@@ -16442,7 +16415,7 @@
                 <a:solidFill>
                   <a:srgbClr val="FF6348"/>
                 </a:solidFill>
-                <a:latin typeface="Calibri"/>
+                <a:latin typeface="Calibri" panose="020F0502020204030204"/>
               </a:defRPr>
             </a:pPr>
             <a:r>
@@ -16523,7 +16496,7 @@
                 <a:solidFill>
                   <a:srgbClr val="00B894"/>
                 </a:solidFill>
-                <a:latin typeface="Calibri"/>
+                <a:latin typeface="Calibri" panose="020F0502020204030204"/>
               </a:defRPr>
             </a:pPr>
             <a:r>
@@ -16604,7 +16577,7 @@
                 <a:solidFill>
                   <a:srgbClr val="FFFFFF"/>
                 </a:solidFill>
-                <a:latin typeface="Calibri"/>
+                <a:latin typeface="Calibri" panose="020F0502020204030204"/>
               </a:defRPr>
             </a:pPr>
             <a:r>
@@ -16685,7 +16658,7 @@
                 <a:solidFill>
                   <a:srgbClr val="FF6348"/>
                 </a:solidFill>
-                <a:latin typeface="Calibri"/>
+                <a:latin typeface="Calibri" panose="020F0502020204030204"/>
               </a:defRPr>
             </a:pPr>
             <a:r>
@@ -16766,7 +16739,7 @@
                 <a:solidFill>
                   <a:srgbClr val="00B894"/>
                 </a:solidFill>
-                <a:latin typeface="Calibri"/>
+                <a:latin typeface="Calibri" panose="020F0502020204030204"/>
               </a:defRPr>
             </a:pPr>
             <a:r>
@@ -16847,7 +16820,7 @@
                 <a:solidFill>
                   <a:srgbClr val="0F0F1A"/>
                 </a:solidFill>
-                <a:latin typeface="Calibri"/>
+                <a:latin typeface="Calibri" panose="020F0502020204030204"/>
               </a:defRPr>
             </a:pPr>
             <a:r>
@@ -16865,7 +16838,7 @@
 </file>
 
 <file path=ppt/slides/slide7.xml><?xml version="1.0" encoding="utf-8"?>
-<p:sld xmlns:a="http://schemas.openxmlformats.org/drawingml/2006/main" xmlns:p="http://schemas.openxmlformats.org/presentationml/2006/main" xmlns:r="http://schemas.openxmlformats.org/officeDocument/2006/relationships">
+<p:sld xmlns:a="http://schemas.openxmlformats.org/drawingml/2006/main" xmlns:r="http://schemas.openxmlformats.org/officeDocument/2006/relationships" xmlns:p="http://schemas.openxmlformats.org/presentationml/2006/main">
   <p:cSld>
     <p:bg>
       <p:bgPr>
@@ -16952,7 +16925,7 @@
                 <a:solidFill>
                   <a:srgbClr val="00B894"/>
                 </a:solidFill>
-                <a:latin typeface="Calibri"/>
+                <a:latin typeface="Calibri" panose="020F0502020204030204"/>
               </a:defRPr>
             </a:pPr>
             <a:r>
@@ -17033,7 +17006,7 @@
                 <a:solidFill>
                   <a:srgbClr val="FFFFFF"/>
                 </a:solidFill>
-                <a:latin typeface="Calibri"/>
+                <a:latin typeface="Calibri" panose="020F0502020204030204"/>
               </a:defRPr>
             </a:pPr>
             <a:r>
@@ -17069,7 +17042,7 @@
                 <a:solidFill>
                   <a:srgbClr val="00B894"/>
                 </a:solidFill>
-                <a:latin typeface="Calibri"/>
+                <a:latin typeface="Calibri" panose="020F0502020204030204"/>
               </a:defRPr>
             </a:pPr>
             <a:r>
@@ -17105,7 +17078,7 @@
                 <a:solidFill>
                   <a:srgbClr val="B0B0C0"/>
                 </a:solidFill>
-                <a:latin typeface="Calibri"/>
+                <a:latin typeface="Calibri" panose="020F0502020204030204"/>
               </a:defRPr>
             </a:pPr>
             <a:r>
@@ -17194,7 +17167,7 @@
                 <a:solidFill>
                   <a:srgbClr val="FFFFFF"/>
                 </a:solidFill>
-                <a:latin typeface="Calibri"/>
+                <a:latin typeface="Calibri" panose="020F0502020204030204"/>
               </a:defRPr>
             </a:pPr>
             <a:r>
@@ -17230,7 +17203,7 @@
                 <a:solidFill>
                   <a:srgbClr val="00B894"/>
                 </a:solidFill>
-                <a:latin typeface="Calibri"/>
+                <a:latin typeface="Calibri" panose="020F0502020204030204"/>
               </a:defRPr>
             </a:pPr>
             <a:r>
@@ -17266,7 +17239,7 @@
                 <a:solidFill>
                   <a:srgbClr val="B0B0C0"/>
                 </a:solidFill>
-                <a:latin typeface="Calibri"/>
+                <a:latin typeface="Calibri" panose="020F0502020204030204"/>
               </a:defRPr>
             </a:pPr>
             <a:r>
@@ -17355,7 +17328,7 @@
                 <a:solidFill>
                   <a:srgbClr val="FFFFFF"/>
                 </a:solidFill>
-                <a:latin typeface="Calibri"/>
+                <a:latin typeface="Calibri" panose="020F0502020204030204"/>
               </a:defRPr>
             </a:pPr>
             <a:r>
@@ -17391,7 +17364,7 @@
                 <a:solidFill>
                   <a:srgbClr val="00B894"/>
                 </a:solidFill>
-                <a:latin typeface="Calibri"/>
+                <a:latin typeface="Calibri" panose="020F0502020204030204"/>
               </a:defRPr>
             </a:pPr>
             <a:r>
@@ -17427,7 +17400,7 @@
                 <a:solidFill>
                   <a:srgbClr val="B0B0C0"/>
                 </a:solidFill>
-                <a:latin typeface="Calibri"/>
+                <a:latin typeface="Calibri" panose="020F0502020204030204"/>
               </a:defRPr>
             </a:pPr>
             <a:r>
@@ -17516,7 +17489,7 @@
                 <a:solidFill>
                   <a:srgbClr val="FFFFFF"/>
                 </a:solidFill>
-                <a:latin typeface="Calibri"/>
+                <a:latin typeface="Calibri" panose="020F0502020204030204"/>
               </a:defRPr>
             </a:pPr>
             <a:r>
@@ -17552,7 +17525,7 @@
                 <a:solidFill>
                   <a:srgbClr val="00B894"/>
                 </a:solidFill>
-                <a:latin typeface="Calibri"/>
+                <a:latin typeface="Calibri" panose="020F0502020204030204"/>
               </a:defRPr>
             </a:pPr>
             <a:r>
@@ -17588,7 +17561,7 @@
                 <a:solidFill>
                   <a:srgbClr val="B0B0C0"/>
                 </a:solidFill>
-                <a:latin typeface="Calibri"/>
+                <a:latin typeface="Calibri" panose="020F0502020204030204"/>
               </a:defRPr>
             </a:pPr>
             <a:r>
@@ -17677,7 +17650,7 @@
                 <a:solidFill>
                   <a:srgbClr val="FFFFFF"/>
                 </a:solidFill>
-                <a:latin typeface="Calibri"/>
+                <a:latin typeface="Calibri" panose="020F0502020204030204"/>
               </a:defRPr>
             </a:pPr>
             <a:r>
@@ -17713,7 +17686,7 @@
                 <a:solidFill>
                   <a:srgbClr val="00B894"/>
                 </a:solidFill>
-                <a:latin typeface="Calibri"/>
+                <a:latin typeface="Calibri" panose="020F0502020204030204"/>
               </a:defRPr>
             </a:pPr>
             <a:r>
@@ -17749,7 +17722,7 @@
                 <a:solidFill>
                   <a:srgbClr val="B0B0C0"/>
                 </a:solidFill>
-                <a:latin typeface="Calibri"/>
+                <a:latin typeface="Calibri" panose="020F0502020204030204"/>
               </a:defRPr>
             </a:pPr>
             <a:r>
@@ -17838,7 +17811,7 @@
                 <a:solidFill>
                   <a:srgbClr val="FFFFFF"/>
                 </a:solidFill>
-                <a:latin typeface="Calibri"/>
+                <a:latin typeface="Calibri" panose="020F0502020204030204"/>
               </a:defRPr>
             </a:pPr>
             <a:r>
@@ -17874,7 +17847,7 @@
                 <a:solidFill>
                   <a:srgbClr val="00B894"/>
                 </a:solidFill>
-                <a:latin typeface="Calibri"/>
+                <a:latin typeface="Calibri" panose="020F0502020204030204"/>
               </a:defRPr>
             </a:pPr>
             <a:r>
@@ -17910,7 +17883,7 @@
                 <a:solidFill>
                   <a:srgbClr val="B0B0C0"/>
                 </a:solidFill>
-                <a:latin typeface="Calibri"/>
+                <a:latin typeface="Calibri" panose="020F0502020204030204"/>
               </a:defRPr>
             </a:pPr>
             <a:r>
@@ -17936,7 +17909,7 @@
 </file>
 
 <file path=ppt/slides/slide8.xml><?xml version="1.0" encoding="utf-8"?>
-<p:sld xmlns:a="http://schemas.openxmlformats.org/drawingml/2006/main" xmlns:p="http://schemas.openxmlformats.org/presentationml/2006/main" xmlns:r="http://schemas.openxmlformats.org/officeDocument/2006/relationships">
+<p:sld xmlns:a="http://schemas.openxmlformats.org/drawingml/2006/main" xmlns:r="http://schemas.openxmlformats.org/officeDocument/2006/relationships" xmlns:p="http://schemas.openxmlformats.org/presentationml/2006/main">
   <p:cSld>
     <p:bg>
       <p:bgPr>
@@ -18023,7 +17996,7 @@
                 <a:solidFill>
                   <a:srgbClr val="6C5CE7"/>
                 </a:solidFill>
-                <a:latin typeface="Calibri"/>
+                <a:latin typeface="Calibri" panose="020F0502020204030204"/>
               </a:defRPr>
             </a:pPr>
             <a:r>
@@ -18104,7 +18077,7 @@
                 <a:solidFill>
                   <a:srgbClr val="6C5CE7"/>
                 </a:solidFill>
-                <a:latin typeface="Calibri"/>
+                <a:latin typeface="Calibri" panose="020F0502020204030204"/>
               </a:defRPr>
             </a:pPr>
             <a:r>
@@ -18140,7 +18113,7 @@
                 <a:solidFill>
                   <a:srgbClr val="B0B0C0"/>
                 </a:solidFill>
-                <a:latin typeface="Consolas"/>
+                <a:latin typeface="Consolas" panose="020B0609020204030204"/>
               </a:defRPr>
             </a:pPr>
             <a:r>
@@ -18262,7 +18235,7 @@
                 <a:solidFill>
                   <a:srgbClr val="00B894"/>
                 </a:solidFill>
-                <a:latin typeface="Calibri"/>
+                <a:latin typeface="Calibri" panose="020F0502020204030204"/>
               </a:defRPr>
             </a:pPr>
             <a:r>
@@ -18298,7 +18271,7 @@
                 <a:solidFill>
                   <a:srgbClr val="B0B0C0"/>
                 </a:solidFill>
-                <a:latin typeface="Consolas"/>
+                <a:latin typeface="Consolas" panose="020B0609020204030204"/>
               </a:defRPr>
             </a:pPr>
             <a:r>
@@ -18366,7 +18339,7 @@
 </file>
 
 <file path=ppt/slides/slide9.xml><?xml version="1.0" encoding="utf-8"?>
-<p:sld xmlns:a="http://schemas.openxmlformats.org/drawingml/2006/main" xmlns:p="http://schemas.openxmlformats.org/presentationml/2006/main" xmlns:r="http://schemas.openxmlformats.org/officeDocument/2006/relationships">
+<p:sld xmlns:a="http://schemas.openxmlformats.org/drawingml/2006/main" xmlns:r="http://schemas.openxmlformats.org/officeDocument/2006/relationships" xmlns:p="http://schemas.openxmlformats.org/presentationml/2006/main">
   <p:cSld>
     <p:bg>
       <p:bgPr>
@@ -18453,7 +18426,7 @@
                 <a:solidFill>
                   <a:srgbClr val="6C5CE7"/>
                 </a:solidFill>
-                <a:latin typeface="Calibri"/>
+                <a:latin typeface="Calibri" panose="020F0502020204030204"/>
               </a:defRPr>
             </a:pPr>
             <a:r>
@@ -18516,7 +18489,7 @@
         <p:spPr>
           <a:xfrm>
             <a:off x="594360" y="1508760"/>
-            <a:ext cx="457200" cy="457200"/>
+            <a:ext cx="457200" cy="491490"/>
           </a:xfrm>
           <a:prstGeom prst="rect">
             <a:avLst/>
@@ -18534,12 +18507,9 @@
                 <a:solidFill>
                   <a:srgbClr val="FFFFFF"/>
                 </a:solidFill>
-                <a:latin typeface="Calibri"/>
-              </a:defRPr>
-            </a:pPr>
-            <a:r>
-              <a:t>🔐</a:t>
-            </a:r>
+                <a:latin typeface="Calibri" panose="020F0502020204030204"/>
+              </a:defRPr>
+            </a:pPr>
           </a:p>
         </p:txBody>
       </p:sp>
@@ -18570,7 +18540,7 @@
                 <a:solidFill>
                   <a:srgbClr val="6C5CE7"/>
                 </a:solidFill>
-                <a:latin typeface="Calibri"/>
+                <a:latin typeface="Calibri" panose="020F0502020204030204"/>
               </a:defRPr>
             </a:pPr>
             <a:r>
@@ -18606,7 +18576,7 @@
                 <a:solidFill>
                   <a:srgbClr val="B0B0C0"/>
                 </a:solidFill>
-                <a:latin typeface="Calibri"/>
+                <a:latin typeface="Calibri" panose="020F0502020204030204"/>
               </a:defRPr>
             </a:pPr>
             <a:r>
@@ -18677,7 +18647,7 @@
         <p:spPr>
           <a:xfrm>
             <a:off x="3474720" y="1508760"/>
-            <a:ext cx="457200" cy="457200"/>
+            <a:ext cx="457200" cy="491490"/>
           </a:xfrm>
           <a:prstGeom prst="rect">
             <a:avLst/>
@@ -18695,12 +18665,9 @@
                 <a:solidFill>
                   <a:srgbClr val="FFFFFF"/>
                 </a:solidFill>
-                <a:latin typeface="Calibri"/>
-              </a:defRPr>
-            </a:pPr>
-            <a:r>
-              <a:t>📺</a:t>
-            </a:r>
+                <a:latin typeface="Calibri" panose="020F0502020204030204"/>
+              </a:defRPr>
+            </a:pPr>
           </a:p>
         </p:txBody>
       </p:sp>
@@ -18731,7 +18698,7 @@
                 <a:solidFill>
                   <a:srgbClr val="00B894"/>
                 </a:solidFill>
-                <a:latin typeface="Calibri"/>
+                <a:latin typeface="Calibri" panose="020F0502020204030204"/>
               </a:defRPr>
             </a:pPr>
             <a:r>
@@ -18767,7 +18734,7 @@
                 <a:solidFill>
                   <a:srgbClr val="B0B0C0"/>
                 </a:solidFill>
-                <a:latin typeface="Calibri"/>
+                <a:latin typeface="Calibri" panose="020F0502020204030204"/>
               </a:defRPr>
             </a:pPr>
             <a:r>
@@ -18838,7 +18805,7 @@
         <p:spPr>
           <a:xfrm>
             <a:off x="6355080" y="1508760"/>
-            <a:ext cx="457200" cy="457200"/>
+            <a:ext cx="457200" cy="491490"/>
           </a:xfrm>
           <a:prstGeom prst="rect">
             <a:avLst/>
@@ -18856,12 +18823,9 @@
                 <a:solidFill>
                   <a:srgbClr val="FFFFFF"/>
                 </a:solidFill>
-                <a:latin typeface="Calibri"/>
-              </a:defRPr>
-            </a:pPr>
-            <a:r>
-              <a:t>👑</a:t>
-            </a:r>
+                <a:latin typeface="Calibri" panose="020F0502020204030204"/>
+              </a:defRPr>
+            </a:pPr>
           </a:p>
         </p:txBody>
       </p:sp>
@@ -18892,7 +18856,7 @@
                 <a:solidFill>
                   <a:srgbClr val="FFD700"/>
                 </a:solidFill>
-                <a:latin typeface="Calibri"/>
+                <a:latin typeface="Calibri" panose="020F0502020204030204"/>
               </a:defRPr>
             </a:pPr>
             <a:r>
@@ -18928,7 +18892,7 @@
                 <a:solidFill>
                   <a:srgbClr val="B0B0C0"/>
                 </a:solidFill>
-                <a:latin typeface="Calibri"/>
+                <a:latin typeface="Calibri" panose="020F0502020204030204"/>
               </a:defRPr>
             </a:pPr>
             <a:r>
@@ -18999,7 +18963,7 @@
         <p:spPr>
           <a:xfrm>
             <a:off x="9235440" y="1508760"/>
-            <a:ext cx="457200" cy="457200"/>
+            <a:ext cx="457200" cy="491490"/>
           </a:xfrm>
           <a:prstGeom prst="rect">
             <a:avLst/>
@@ -19017,12 +18981,9 @@
                 <a:solidFill>
                   <a:srgbClr val="FFFFFF"/>
                 </a:solidFill>
-                <a:latin typeface="Calibri"/>
-              </a:defRPr>
-            </a:pPr>
-            <a:r>
-              <a:t>📂</a:t>
-            </a:r>
+                <a:latin typeface="Calibri" panose="020F0502020204030204"/>
+              </a:defRPr>
+            </a:pPr>
           </a:p>
         </p:txBody>
       </p:sp>
@@ -19053,7 +19014,7 @@
                 <a:solidFill>
                   <a:srgbClr val="00B4D8"/>
                 </a:solidFill>
-                <a:latin typeface="Calibri"/>
+                <a:latin typeface="Calibri" panose="020F0502020204030204"/>
               </a:defRPr>
             </a:pPr>
             <a:r>
@@ -19089,7 +19050,7 @@
                 <a:solidFill>
                   <a:srgbClr val="B0B0C0"/>
                 </a:solidFill>
-                <a:latin typeface="Calibri"/>
+                <a:latin typeface="Calibri" panose="020F0502020204030204"/>
               </a:defRPr>
             </a:pPr>
             <a:r>
@@ -19160,7 +19121,7 @@
         <p:spPr>
           <a:xfrm>
             <a:off x="594360" y="4069080"/>
-            <a:ext cx="457200" cy="457200"/>
+            <a:ext cx="457200" cy="491490"/>
           </a:xfrm>
           <a:prstGeom prst="rect">
             <a:avLst/>
@@ -19178,12 +19139,9 @@
                 <a:solidFill>
                   <a:srgbClr val="FFFFFF"/>
                 </a:solidFill>
-                <a:latin typeface="Calibri"/>
-              </a:defRPr>
-            </a:pPr>
-            <a:r>
-              <a:t>📋</a:t>
-            </a:r>
+                <a:latin typeface="Calibri" panose="020F0502020204030204"/>
+              </a:defRPr>
+            </a:pPr>
           </a:p>
         </p:txBody>
       </p:sp>
@@ -19214,7 +19172,7 @@
                 <a:solidFill>
                   <a:srgbClr val="FFA000"/>
                 </a:solidFill>
-                <a:latin typeface="Calibri"/>
+                <a:latin typeface="Calibri" panose="020F0502020204030204"/>
               </a:defRPr>
             </a:pPr>
             <a:r>
@@ -19250,7 +19208,7 @@
                 <a:solidFill>
                   <a:srgbClr val="B0B0C0"/>
                 </a:solidFill>
-                <a:latin typeface="Calibri"/>
+                <a:latin typeface="Calibri" panose="020F0502020204030204"/>
               </a:defRPr>
             </a:pPr>
             <a:r>
@@ -19321,7 +19279,7 @@
         <p:spPr>
           <a:xfrm>
             <a:off x="3474720" y="4069080"/>
-            <a:ext cx="457200" cy="457200"/>
+            <a:ext cx="457200" cy="491490"/>
           </a:xfrm>
           <a:prstGeom prst="rect">
             <a:avLst/>
@@ -19339,12 +19297,9 @@
                 <a:solidFill>
                   <a:srgbClr val="FFFFFF"/>
                 </a:solidFill>
-                <a:latin typeface="Calibri"/>
-              </a:defRPr>
-            </a:pPr>
-            <a:r>
-              <a:t>⏱</a:t>
-            </a:r>
+                <a:latin typeface="Calibri" panose="020F0502020204030204"/>
+              </a:defRPr>
+            </a:pPr>
           </a:p>
         </p:txBody>
       </p:sp>
@@ -19375,7 +19330,7 @@
                 <a:solidFill>
                   <a:srgbClr val="00B894"/>
                 </a:solidFill>
-                <a:latin typeface="Calibri"/>
+                <a:latin typeface="Calibri" panose="020F0502020204030204"/>
               </a:defRPr>
             </a:pPr>
             <a:r>
@@ -19411,7 +19366,7 @@
                 <a:solidFill>
                   <a:srgbClr val="B0B0C0"/>
                 </a:solidFill>
-                <a:latin typeface="Calibri"/>
+                <a:latin typeface="Calibri" panose="020F0502020204030204"/>
               </a:defRPr>
             </a:pPr>
             <a:r>
@@ -19482,7 +19437,7 @@
         <p:spPr>
           <a:xfrm>
             <a:off x="6355080" y="4069080"/>
-            <a:ext cx="457200" cy="457200"/>
+            <a:ext cx="457200" cy="491490"/>
           </a:xfrm>
           <a:prstGeom prst="rect">
             <a:avLst/>
@@ -19500,12 +19455,9 @@
                 <a:solidFill>
                   <a:srgbClr val="FFFFFF"/>
                 </a:solidFill>
-                <a:latin typeface="Calibri"/>
-              </a:defRPr>
-            </a:pPr>
-            <a:r>
-              <a:t>🔍</a:t>
-            </a:r>
+                <a:latin typeface="Calibri" panose="020F0502020204030204"/>
+              </a:defRPr>
+            </a:pPr>
           </a:p>
         </p:txBody>
       </p:sp>
@@ -19536,7 +19488,7 @@
                 <a:solidFill>
                   <a:srgbClr val="00B4D8"/>
                 </a:solidFill>
-                <a:latin typeface="Calibri"/>
+                <a:latin typeface="Calibri" panose="020F0502020204030204"/>
               </a:defRPr>
             </a:pPr>
             <a:r>
@@ -19572,7 +19524,7 @@
                 <a:solidFill>
                   <a:srgbClr val="B0B0C0"/>
                 </a:solidFill>
-                <a:latin typeface="Calibri"/>
+                <a:latin typeface="Calibri" panose="020F0502020204030204"/>
               </a:defRPr>
             </a:pPr>
             <a:r>
@@ -19643,7 +19595,7 @@
         <p:spPr>
           <a:xfrm>
             <a:off x="9235440" y="4069080"/>
-            <a:ext cx="457200" cy="457200"/>
+            <a:ext cx="457200" cy="491490"/>
           </a:xfrm>
           <a:prstGeom prst="rect">
             <a:avLst/>
@@ -19661,12 +19613,9 @@
                 <a:solidFill>
                   <a:srgbClr val="FFFFFF"/>
                 </a:solidFill>
-                <a:latin typeface="Calibri"/>
-              </a:defRPr>
-            </a:pPr>
-            <a:r>
-              <a:t>🛠</a:t>
-            </a:r>
+                <a:latin typeface="Calibri" panose="020F0502020204030204"/>
+              </a:defRPr>
+            </a:pPr>
           </a:p>
         </p:txBody>
       </p:sp>
@@ -19697,7 +19646,7 @@
                 <a:solidFill>
                   <a:srgbClr val="FF6348"/>
                 </a:solidFill>
-                <a:latin typeface="Calibri"/>
+                <a:latin typeface="Calibri" panose="020F0502020204030204"/>
               </a:defRPr>
             </a:pPr>
             <a:r>
@@ -19733,7 +19682,7 @@
                 <a:solidFill>
                   <a:srgbClr val="B0B0C0"/>
                 </a:solidFill>
-                <a:latin typeface="Calibri"/>
+                <a:latin typeface="Calibri" panose="020F0502020204030204"/>
               </a:defRPr>
             </a:pPr>
             <a:r>
@@ -20074,6 +20023,10 @@
       </a:style>
     </a:lnDef>
   </a:objectDefaults>
-  <a:extraClrSchemeLst/>
+  <a:extLst>
+    <a:ext uri="{05A4C25C-085E-4340-85A3-A5531E510DB2}">
+      <thm15:themeFamily xmlns:thm15="http://schemas.microsoft.com/office/thememl/2012/main" name="Office Theme" id="{62F939B6-93AF-4DB8-9C6B-D6C7DFDC589F}" vid="{4A3C46E8-61CC-4603-A589-7422A47A8E4A}"/>
+    </a:ext>
+  </a:extLst>
 </a:theme>
 </file>
</xml_diff>